<commit_message>
Remove stray gold rules; align logo rules to WOMEN/COURSE; add previews
Co-Authored-By: Claude Opus 5.5 <noreply@anthropic.com>
Claude-Session: https://claude.ai/code/session_01JDwQw7JjDqKz2VPXW7wT25
</commit_message>
<xml_diff>
--- a/size-charts/womens-pant-size-chart-canva.pptx
+++ b/size-charts/womens-pant-size-chart-canva.pptx
@@ -3169,8 +3169,8 @@
         </p:nvSpPr>
         <p:spPr>
           <a:xfrm>
-            <a:off x="2232273" y="827782"/>
-            <a:ext cx="3095327" cy="558850"/>
+            <a:off x="2422773" y="827782"/>
+            <a:ext cx="2714327" cy="558850"/>
           </a:xfrm>
           <a:prstGeom prst="rect">
             <a:avLst/>
@@ -3183,7 +3183,7 @@
           </a:bodyPr>
           <a:lstStyle/>
           <a:p>
-            <a:pPr algn="ctr"/>
+            <a:pPr algn="l"/>
             <a:r>
               <a:rPr sz="4400" b="0" i="0" spc="88">
                 <a:solidFill>
@@ -3205,7 +3205,7 @@
         <p:spPr>
           <a:xfrm>
             <a:off x="2422773" y="1612999"/>
-            <a:ext cx="972741" cy="7144"/>
+            <a:ext cx="973693" cy="7144"/>
           </a:xfrm>
           <a:prstGeom prst="rect">
             <a:avLst/>
@@ -3234,8 +3234,8 @@
         </p:nvSpPr>
         <p:spPr>
           <a:xfrm>
-            <a:off x="4164509" y="1612999"/>
-            <a:ext cx="972592" cy="7144"/>
+            <a:off x="4163556" y="1612999"/>
+            <a:ext cx="973544" cy="7144"/>
           </a:xfrm>
           <a:prstGeom prst="rect">
             <a:avLst/>
@@ -3299,8 +3299,8 @@
         </p:nvSpPr>
         <p:spPr>
           <a:xfrm>
-            <a:off x="2232273" y="1875383"/>
-            <a:ext cx="3095327" cy="558850"/>
+            <a:off x="2422773" y="1875383"/>
+            <a:ext cx="2714327" cy="558850"/>
           </a:xfrm>
           <a:prstGeom prst="rect">
             <a:avLst/>
@@ -3313,7 +3313,7 @@
           </a:bodyPr>
           <a:lstStyle/>
           <a:p>
-            <a:pPr algn="ctr"/>
+            <a:pPr algn="r"/>
             <a:r>
               <a:rPr sz="4400" b="0" i="0" spc="88">
                 <a:solidFill>
@@ -3363,31 +3363,36 @@
       </p:sp>
       <p:sp>
         <p:nvSpPr>
-          <p:cNvPr id="10" name="Rectangle 9"/>
-          <p:cNvSpPr/>
-          <p:nvPr/>
-        </p:nvSpPr>
-        <p:spPr>
-          <a:xfrm>
-            <a:off x="3383905" y="3081933"/>
-            <a:ext cx="791914" cy="7144"/>
-          </a:xfrm>
-          <a:prstGeom prst="rect">
-            <a:avLst/>
-          </a:prstGeom>
-          <a:solidFill>
-            <a:srgbClr val="9E7A38"/>
-          </a:solidFill>
-          <a:ln>
-            <a:noFill/>
-          </a:ln>
-          <a:effectLst/>
-        </p:spPr>
-        <p:txBody>
-          <a:bodyPr rtlCol="0" anchor="ctr"/>
-          <a:lstStyle/>
-          <a:p>
-            <a:pPr algn="ctr"/>
+          <p:cNvPr id="10" name="TextBox 9"/>
+          <p:cNvSpPr txBox="1"/>
+          <p:nvPr/>
+        </p:nvSpPr>
+        <p:spPr>
+          <a:xfrm>
+            <a:off x="1466850" y="3333899"/>
+            <a:ext cx="4626025" cy="266700"/>
+          </a:xfrm>
+          <a:prstGeom prst="rect">
+            <a:avLst/>
+          </a:prstGeom>
+          <a:noFill/>
+        </p:spPr>
+        <p:txBody>
+          <a:bodyPr wrap="none" lIns="0" rIns="0" tIns="0" bIns="0" anchor="ctr">
+            <a:spAutoFit/>
+          </a:bodyPr>
+          <a:lstStyle/>
+          <a:p>
+            <a:pPr algn="ctr"/>
+            <a:r>
+              <a:rPr sz="1700" b="0" i="0" spc="646">
+                <a:solidFill>
+                  <a:srgbClr val="1F2A44"/>
+                </a:solidFill>
+                <a:latin typeface="Montserrat"/>
+              </a:rPr>
+              <a:t>WOMEN’S PANT SIZING</a:t>
+            </a:r>
           </a:p>
         </p:txBody>
       </p:sp>
@@ -3399,8 +3404,8 @@
         </p:nvSpPr>
         <p:spPr>
           <a:xfrm>
-            <a:off x="1466850" y="3333899"/>
-            <a:ext cx="4626025" cy="266700"/>
+            <a:off x="2430363" y="3744516"/>
+            <a:ext cx="2698998" cy="133350"/>
           </a:xfrm>
           <a:prstGeom prst="rect">
             <a:avLst/>
@@ -3415,13 +3420,13 @@
           <a:p>
             <a:pPr algn="ctr"/>
             <a:r>
-              <a:rPr sz="1700" b="0" i="0" spc="646">
-                <a:solidFill>
-                  <a:srgbClr val="1F2A44"/>
+              <a:rPr sz="850" b="0" i="0" spc="340">
+                <a:solidFill>
+                  <a:srgbClr val="9E7A38"/>
                 </a:solidFill>
                 <a:latin typeface="Montserrat"/>
               </a:rPr>
-              <a:t>WOMEN’S PANT SIZING</a:t>
+              <a:t>SIZE CONVERSION GUIDE</a:t>
             </a:r>
           </a:p>
         </p:txBody>
@@ -3434,8 +3439,8 @@
         </p:nvSpPr>
         <p:spPr>
           <a:xfrm>
-            <a:off x="2430363" y="3744516"/>
-            <a:ext cx="2698998" cy="133350"/>
+            <a:off x="647998" y="4309765"/>
+            <a:ext cx="3496866" cy="174575"/>
           </a:xfrm>
           <a:prstGeom prst="rect">
             <a:avLst/>
@@ -3450,13 +3455,13 @@
           <a:p>
             <a:pPr algn="ctr"/>
             <a:r>
-              <a:rPr sz="850" b="0" i="0" spc="340">
+              <a:rPr sz="750" b="0" i="0" spc="285">
                 <a:solidFill>
                   <a:srgbClr val="9E7A38"/>
                 </a:solidFill>
                 <a:latin typeface="Montserrat"/>
               </a:rPr>
-              <a:t>SIZE CONVERSION GUIDE</a:t>
+              <a:t>INTERNATIONAL</a:t>
             </a:r>
           </a:p>
         </p:txBody>
@@ -3469,8 +3474,8 @@
         </p:nvSpPr>
         <p:spPr>
           <a:xfrm>
-            <a:off x="647998" y="4309765"/>
-            <a:ext cx="3496866" cy="179338"/>
+            <a:off x="4288780" y="4309765"/>
+            <a:ext cx="2623096" cy="174575"/>
           </a:xfrm>
           <a:prstGeom prst="rect">
             <a:avLst/>
@@ -3491,7 +3496,7 @@
                 </a:solidFill>
                 <a:latin typeface="Montserrat"/>
               </a:rPr>
-              <a:t>INTERNATIONAL</a:t>
+              <a:t>BY BRAND</a:t>
             </a:r>
           </a:p>
         </p:txBody>
@@ -3504,103 +3509,8 @@
         </p:nvSpPr>
         <p:spPr>
           <a:xfrm>
-            <a:off x="647998" y="4539109"/>
-            <a:ext cx="3496866" cy="7144"/>
-          </a:xfrm>
-          <a:prstGeom prst="rect">
-            <a:avLst/>
-          </a:prstGeom>
-          <a:solidFill>
-            <a:srgbClr val="9E7A38"/>
-          </a:solidFill>
-          <a:ln>
-            <a:noFill/>
-          </a:ln>
-          <a:effectLst/>
-        </p:spPr>
-        <p:txBody>
-          <a:bodyPr rtlCol="0" anchor="ctr"/>
-          <a:lstStyle/>
-          <a:p>
-            <a:pPr algn="ctr"/>
-          </a:p>
-        </p:txBody>
-      </p:sp>
-      <p:sp>
-        <p:nvSpPr>
-          <p:cNvPr id="15" name="TextBox 14"/>
-          <p:cNvSpPr txBox="1"/>
-          <p:nvPr/>
-        </p:nvSpPr>
-        <p:spPr>
-          <a:xfrm>
-            <a:off x="4288780" y="4309765"/>
-            <a:ext cx="2623096" cy="179338"/>
-          </a:xfrm>
-          <a:prstGeom prst="rect">
-            <a:avLst/>
-          </a:prstGeom>
-          <a:noFill/>
-        </p:spPr>
-        <p:txBody>
-          <a:bodyPr wrap="none" lIns="0" rIns="0" tIns="0" bIns="0" anchor="ctr">
-            <a:spAutoFit/>
-          </a:bodyPr>
-          <a:lstStyle/>
-          <a:p>
-            <a:pPr algn="ctr"/>
-            <a:r>
-              <a:rPr sz="750" b="0" i="0" spc="285">
-                <a:solidFill>
-                  <a:srgbClr val="9E7A38"/>
-                </a:solidFill>
-                <a:latin typeface="Montserrat"/>
-              </a:rPr>
-              <a:t>BY BRAND</a:t>
-            </a:r>
-          </a:p>
-        </p:txBody>
-      </p:sp>
-      <p:sp>
-        <p:nvSpPr>
-          <p:cNvPr id="16" name="Rectangle 15"/>
-          <p:cNvSpPr/>
-          <p:nvPr/>
-        </p:nvSpPr>
-        <p:spPr>
-          <a:xfrm>
-            <a:off x="4288780" y="4539109"/>
-            <a:ext cx="2623096" cy="7144"/>
-          </a:xfrm>
-          <a:prstGeom prst="rect">
-            <a:avLst/>
-          </a:prstGeom>
-          <a:solidFill>
-            <a:srgbClr val="9E7A38"/>
-          </a:solidFill>
-          <a:ln>
-            <a:noFill/>
-          </a:ln>
-          <a:effectLst/>
-        </p:spPr>
-        <p:txBody>
-          <a:bodyPr rtlCol="0" anchor="ctr"/>
-          <a:lstStyle/>
-          <a:p>
-            <a:pPr algn="ctr"/>
-          </a:p>
-        </p:txBody>
-      </p:sp>
-      <p:sp>
-        <p:nvSpPr>
-          <p:cNvPr id="17" name="Rectangle 16"/>
-          <p:cNvSpPr/>
-          <p:nvPr/>
-        </p:nvSpPr>
-        <p:spPr>
-          <a:xfrm>
-            <a:off x="647998" y="4546253"/>
-            <a:ext cx="3496866" cy="497979"/>
+            <a:off x="647998" y="4541490"/>
+            <a:ext cx="3496866" cy="493216"/>
           </a:xfrm>
           <a:prstGeom prst="rect">
             <a:avLst/>
@@ -3623,14 +3533,14 @@
       </p:sp>
       <p:sp>
         <p:nvSpPr>
-          <p:cNvPr id="18" name="Rectangle 17"/>
+          <p:cNvPr id="15" name="Rectangle 14"/>
           <p:cNvSpPr/>
           <p:nvPr/>
         </p:nvSpPr>
         <p:spPr>
           <a:xfrm>
-            <a:off x="4288780" y="4546253"/>
-            <a:ext cx="2623096" cy="497979"/>
+            <a:off x="4288780" y="4541490"/>
+            <a:ext cx="2623096" cy="493216"/>
           </a:xfrm>
           <a:prstGeom prst="rect">
             <a:avLst/>
@@ -3653,14 +3563,119 @@
       </p:sp>
       <p:sp>
         <p:nvSpPr>
+          <p:cNvPr id="16" name="TextBox 15"/>
+          <p:cNvSpPr txBox="1"/>
+          <p:nvPr/>
+        </p:nvSpPr>
+        <p:spPr>
+          <a:xfrm>
+            <a:off x="647998" y="4541490"/>
+            <a:ext cx="874216" cy="493216"/>
+          </a:xfrm>
+          <a:prstGeom prst="rect">
+            <a:avLst/>
+          </a:prstGeom>
+          <a:noFill/>
+        </p:spPr>
+        <p:txBody>
+          <a:bodyPr wrap="none" lIns="0" rIns="0" tIns="0" bIns="0" anchor="ctr">
+            <a:spAutoFit/>
+          </a:bodyPr>
+          <a:lstStyle/>
+          <a:p>
+            <a:pPr algn="ctr"/>
+            <a:r>
+              <a:rPr sz="850" b="0" i="0" spc="204">
+                <a:solidFill>
+                  <a:srgbClr val="E4D3B0"/>
+                </a:solidFill>
+                <a:latin typeface="Montserrat"/>
+              </a:rPr>
+              <a:t>AUST</a:t>
+            </a:r>
+          </a:p>
+        </p:txBody>
+      </p:sp>
+      <p:sp>
+        <p:nvSpPr>
+          <p:cNvPr id="17" name="TextBox 16"/>
+          <p:cNvSpPr txBox="1"/>
+          <p:nvPr/>
+        </p:nvSpPr>
+        <p:spPr>
+          <a:xfrm>
+            <a:off x="1522214" y="4541490"/>
+            <a:ext cx="874216" cy="493216"/>
+          </a:xfrm>
+          <a:prstGeom prst="rect">
+            <a:avLst/>
+          </a:prstGeom>
+          <a:noFill/>
+        </p:spPr>
+        <p:txBody>
+          <a:bodyPr wrap="none" lIns="0" rIns="0" tIns="0" bIns="0" anchor="ctr">
+            <a:spAutoFit/>
+          </a:bodyPr>
+          <a:lstStyle/>
+          <a:p>
+            <a:pPr algn="ctr"/>
+            <a:r>
+              <a:rPr sz="850" b="0" i="0" spc="204">
+                <a:solidFill>
+                  <a:srgbClr val="E4D3B0"/>
+                </a:solidFill>
+                <a:latin typeface="Montserrat"/>
+              </a:rPr>
+              <a:t>UK</a:t>
+            </a:r>
+          </a:p>
+        </p:txBody>
+      </p:sp>
+      <p:sp>
+        <p:nvSpPr>
+          <p:cNvPr id="18" name="TextBox 17"/>
+          <p:cNvSpPr txBox="1"/>
+          <p:nvPr/>
+        </p:nvSpPr>
+        <p:spPr>
+          <a:xfrm>
+            <a:off x="2396430" y="4541490"/>
+            <a:ext cx="874216" cy="493216"/>
+          </a:xfrm>
+          <a:prstGeom prst="rect">
+            <a:avLst/>
+          </a:prstGeom>
+          <a:noFill/>
+        </p:spPr>
+        <p:txBody>
+          <a:bodyPr wrap="none" lIns="0" rIns="0" tIns="0" bIns="0" anchor="ctr">
+            <a:spAutoFit/>
+          </a:bodyPr>
+          <a:lstStyle/>
+          <a:p>
+            <a:pPr algn="ctr"/>
+            <a:r>
+              <a:rPr sz="850" b="0" i="0" spc="204">
+                <a:solidFill>
+                  <a:srgbClr val="E4D3B0"/>
+                </a:solidFill>
+                <a:latin typeface="Montserrat"/>
+              </a:rPr>
+              <a:t>USA</a:t>
+            </a:r>
+          </a:p>
+        </p:txBody>
+      </p:sp>
+      <p:sp>
+        <p:nvSpPr>
           <p:cNvPr id="19" name="TextBox 18"/>
           <p:cNvSpPr txBox="1"/>
           <p:nvPr/>
         </p:nvSpPr>
         <p:spPr>
           <a:xfrm>
-            <a:off x="647998" y="4546253"/>
-            <a:ext cx="874216" cy="497979"/>
+            <a:off x="3270647" y="4541490"/>
+            <a:ext cx="874216" cy="493216"/>
           </a:xfrm>
           <a:prstGeom prst="rect">
             <a:avLst/>
@@ -3681,7 +3696,7 @@
                 </a:solidFill>
                 <a:latin typeface="Montserrat"/>
               </a:rPr>
-              <a:t>AUST</a:t>
+              <a:t>EURO</a:t>
             </a:r>
           </a:p>
         </p:txBody>
@@ -3694,8 +3709,8 @@
         </p:nvSpPr>
         <p:spPr>
           <a:xfrm>
-            <a:off x="1522214" y="4546253"/>
-            <a:ext cx="874216" cy="497979"/>
+            <a:off x="4288780" y="4541490"/>
+            <a:ext cx="874216" cy="493216"/>
           </a:xfrm>
           <a:prstGeom prst="rect">
             <a:avLst/>
@@ -3710,13 +3725,13 @@
           <a:p>
             <a:pPr algn="ctr"/>
             <a:r>
-              <a:rPr sz="850" b="0" i="0" spc="204">
-                <a:solidFill>
-                  <a:srgbClr val="E4D3B0"/>
+              <a:rPr sz="750" b="0" i="0" spc="105">
+                <a:solidFill>
+                  <a:srgbClr val="F8F5F1"/>
                 </a:solidFill>
                 <a:latin typeface="Montserrat"/>
               </a:rPr>
-              <a:t>UK</a:t>
+              <a:t>RÖHNISCH</a:t>
             </a:r>
           </a:p>
         </p:txBody>
@@ -3729,8 +3744,8 @@
         </p:nvSpPr>
         <p:spPr>
           <a:xfrm>
-            <a:off x="2396430" y="4546253"/>
-            <a:ext cx="874216" cy="497979"/>
+            <a:off x="5162996" y="4541490"/>
+            <a:ext cx="874216" cy="493216"/>
           </a:xfrm>
           <a:prstGeom prst="rect">
             <a:avLst/>
@@ -3745,13 +3760,13 @@
           <a:p>
             <a:pPr algn="ctr"/>
             <a:r>
-              <a:rPr sz="850" b="0" i="0" spc="204">
-                <a:solidFill>
-                  <a:srgbClr val="E4D3B0"/>
+              <a:rPr sz="750" b="0" i="0" spc="105">
+                <a:solidFill>
+                  <a:srgbClr val="F8F5F1"/>
                 </a:solidFill>
                 <a:latin typeface="Montserrat"/>
               </a:rPr>
-              <a:t>USA</a:t>
+              <a:t>J.LINDEBERG</a:t>
             </a:r>
           </a:p>
         </p:txBody>
@@ -3764,8 +3779,8 @@
         </p:nvSpPr>
         <p:spPr>
           <a:xfrm>
-            <a:off x="3270647" y="4546253"/>
-            <a:ext cx="874216" cy="497979"/>
+            <a:off x="6037213" y="4541490"/>
+            <a:ext cx="874663" cy="493216"/>
           </a:xfrm>
           <a:prstGeom prst="rect">
             <a:avLst/>
@@ -3780,117 +3795,12 @@
           <a:p>
             <a:pPr algn="ctr"/>
             <a:r>
-              <a:rPr sz="850" b="0" i="0" spc="204">
-                <a:solidFill>
-                  <a:srgbClr val="E4D3B0"/>
+              <a:rPr sz="750" b="0" i="0" spc="105">
+                <a:solidFill>
+                  <a:srgbClr val="F8F5F1"/>
                 </a:solidFill>
                 <a:latin typeface="Montserrat"/>
               </a:rPr>
-              <a:t>EURO</a:t>
-            </a:r>
-          </a:p>
-        </p:txBody>
-      </p:sp>
-      <p:sp>
-        <p:nvSpPr>
-          <p:cNvPr id="23" name="TextBox 22"/>
-          <p:cNvSpPr txBox="1"/>
-          <p:nvPr/>
-        </p:nvSpPr>
-        <p:spPr>
-          <a:xfrm>
-            <a:off x="4288780" y="4546253"/>
-            <a:ext cx="874216" cy="497979"/>
-          </a:xfrm>
-          <a:prstGeom prst="rect">
-            <a:avLst/>
-          </a:prstGeom>
-          <a:noFill/>
-        </p:spPr>
-        <p:txBody>
-          <a:bodyPr wrap="none" lIns="0" rIns="0" tIns="0" bIns="0" anchor="ctr">
-            <a:spAutoFit/>
-          </a:bodyPr>
-          <a:lstStyle/>
-          <a:p>
-            <a:pPr algn="ctr"/>
-            <a:r>
-              <a:rPr sz="750" b="0" i="0" spc="105">
-                <a:solidFill>
-                  <a:srgbClr val="F8F5F1"/>
-                </a:solidFill>
-                <a:latin typeface="Montserrat"/>
-              </a:rPr>
-              <a:t>RÖHNISCH</a:t>
-            </a:r>
-          </a:p>
-        </p:txBody>
-      </p:sp>
-      <p:sp>
-        <p:nvSpPr>
-          <p:cNvPr id="24" name="TextBox 23"/>
-          <p:cNvSpPr txBox="1"/>
-          <p:nvPr/>
-        </p:nvSpPr>
-        <p:spPr>
-          <a:xfrm>
-            <a:off x="5162996" y="4546253"/>
-            <a:ext cx="874216" cy="497979"/>
-          </a:xfrm>
-          <a:prstGeom prst="rect">
-            <a:avLst/>
-          </a:prstGeom>
-          <a:noFill/>
-        </p:spPr>
-        <p:txBody>
-          <a:bodyPr wrap="none" lIns="0" rIns="0" tIns="0" bIns="0" anchor="ctr">
-            <a:spAutoFit/>
-          </a:bodyPr>
-          <a:lstStyle/>
-          <a:p>
-            <a:pPr algn="ctr"/>
-            <a:r>
-              <a:rPr sz="750" b="0" i="0" spc="105">
-                <a:solidFill>
-                  <a:srgbClr val="F8F5F1"/>
-                </a:solidFill>
-                <a:latin typeface="Montserrat"/>
-              </a:rPr>
-              <a:t>J.LINDEBERG</a:t>
-            </a:r>
-          </a:p>
-        </p:txBody>
-      </p:sp>
-      <p:sp>
-        <p:nvSpPr>
-          <p:cNvPr id="25" name="TextBox 24"/>
-          <p:cNvSpPr txBox="1"/>
-          <p:nvPr/>
-        </p:nvSpPr>
-        <p:spPr>
-          <a:xfrm>
-            <a:off x="6037213" y="4546253"/>
-            <a:ext cx="874663" cy="497979"/>
-          </a:xfrm>
-          <a:prstGeom prst="rect">
-            <a:avLst/>
-          </a:prstGeom>
-          <a:noFill/>
-        </p:spPr>
-        <p:txBody>
-          <a:bodyPr wrap="none" lIns="0" rIns="0" tIns="0" bIns="0" anchor="ctr">
-            <a:spAutoFit/>
-          </a:bodyPr>
-          <a:lstStyle/>
-          <a:p>
-            <a:pPr algn="ctr"/>
-            <a:r>
-              <a:rPr sz="750" b="0" i="0" spc="105">
-                <a:solidFill>
-                  <a:srgbClr val="F8F5F1"/>
-                </a:solidFill>
-                <a:latin typeface="Montserrat"/>
-              </a:rPr>
               <a:t>NIVO</a:t>
             </a:r>
           </a:p>
@@ -3898,13 +3808,13 @@
       </p:sp>
       <p:sp>
         <p:nvSpPr>
-          <p:cNvPr id="26" name="Rectangle 25"/>
+          <p:cNvPr id="23" name="Rectangle 22"/>
           <p:cNvSpPr/>
           <p:nvPr/>
         </p:nvSpPr>
         <p:spPr>
           <a:xfrm>
-            <a:off x="647998" y="5630019"/>
+            <a:off x="647998" y="5620494"/>
             <a:ext cx="3496866" cy="7144"/>
           </a:xfrm>
           <a:prstGeom prst="rect">
@@ -3928,13 +3838,13 @@
       </p:sp>
       <p:sp>
         <p:nvSpPr>
-          <p:cNvPr id="27" name="Rectangle 26"/>
+          <p:cNvPr id="24" name="Rectangle 23"/>
           <p:cNvSpPr/>
           <p:nvPr/>
         </p:nvSpPr>
         <p:spPr>
           <a:xfrm>
-            <a:off x="4288780" y="5630019"/>
+            <a:off x="4288780" y="5620494"/>
             <a:ext cx="2623096" cy="7144"/>
           </a:xfrm>
           <a:prstGeom prst="rect">
@@ -3958,13 +3868,118 @@
       </p:sp>
       <p:sp>
         <p:nvSpPr>
+          <p:cNvPr id="25" name="TextBox 24"/>
+          <p:cNvSpPr txBox="1"/>
+          <p:nvPr/>
+        </p:nvSpPr>
+        <p:spPr>
+          <a:xfrm>
+            <a:off x="647998" y="5034707"/>
+            <a:ext cx="874216" cy="592931"/>
+          </a:xfrm>
+          <a:prstGeom prst="rect">
+            <a:avLst/>
+          </a:prstGeom>
+          <a:noFill/>
+        </p:spPr>
+        <p:txBody>
+          <a:bodyPr wrap="none" lIns="0" rIns="0" tIns="0" bIns="0" anchor="ctr">
+            <a:spAutoFit/>
+          </a:bodyPr>
+          <a:lstStyle/>
+          <a:p>
+            <a:pPr algn="ctr"/>
+            <a:r>
+              <a:rPr sz="1500" b="1" i="0">
+                <a:solidFill>
+                  <a:srgbClr val="1F2A44"/>
+                </a:solidFill>
+                <a:latin typeface="Playfair Display"/>
+              </a:rPr>
+              <a:t>4</a:t>
+            </a:r>
+          </a:p>
+        </p:txBody>
+      </p:sp>
+      <p:sp>
+        <p:nvSpPr>
+          <p:cNvPr id="26" name="TextBox 25"/>
+          <p:cNvSpPr txBox="1"/>
+          <p:nvPr/>
+        </p:nvSpPr>
+        <p:spPr>
+          <a:xfrm>
+            <a:off x="1522214" y="5034707"/>
+            <a:ext cx="874216" cy="592931"/>
+          </a:xfrm>
+          <a:prstGeom prst="rect">
+            <a:avLst/>
+          </a:prstGeom>
+          <a:noFill/>
+        </p:spPr>
+        <p:txBody>
+          <a:bodyPr wrap="none" lIns="0" rIns="0" tIns="0" bIns="0" anchor="ctr">
+            <a:spAutoFit/>
+          </a:bodyPr>
+          <a:lstStyle/>
+          <a:p>
+            <a:pPr algn="ctr"/>
+            <a:r>
+              <a:rPr sz="1500" b="0" i="0">
+                <a:solidFill>
+                  <a:srgbClr val="1F2A44"/>
+                </a:solidFill>
+                <a:latin typeface="Playfair Display"/>
+              </a:rPr>
+              <a:t>4</a:t>
+            </a:r>
+          </a:p>
+        </p:txBody>
+      </p:sp>
+      <p:sp>
+        <p:nvSpPr>
+          <p:cNvPr id="27" name="TextBox 26"/>
+          <p:cNvSpPr txBox="1"/>
+          <p:nvPr/>
+        </p:nvSpPr>
+        <p:spPr>
+          <a:xfrm>
+            <a:off x="2396430" y="5034707"/>
+            <a:ext cx="874216" cy="592931"/>
+          </a:xfrm>
+          <a:prstGeom prst="rect">
+            <a:avLst/>
+          </a:prstGeom>
+          <a:noFill/>
+        </p:spPr>
+        <p:txBody>
+          <a:bodyPr wrap="none" lIns="0" rIns="0" tIns="0" bIns="0" anchor="ctr">
+            <a:spAutoFit/>
+          </a:bodyPr>
+          <a:lstStyle/>
+          <a:p>
+            <a:pPr algn="ctr"/>
+            <a:r>
+              <a:rPr sz="1500" b="0" i="0">
+                <a:solidFill>
+                  <a:srgbClr val="1F2A44"/>
+                </a:solidFill>
+                <a:latin typeface="Playfair Display"/>
+              </a:rPr>
+              <a:t>0</a:t>
+            </a:r>
+          </a:p>
+        </p:txBody>
+      </p:sp>
+      <p:sp>
+        <p:nvSpPr>
           <p:cNvPr id="28" name="TextBox 27"/>
           <p:cNvSpPr txBox="1"/>
           <p:nvPr/>
         </p:nvSpPr>
         <p:spPr>
           <a:xfrm>
-            <a:off x="647998" y="5044232"/>
+            <a:off x="3270647" y="5034707"/>
             <a:ext cx="874216" cy="592931"/>
           </a:xfrm>
           <a:prstGeom prst="rect">
@@ -3980,13 +3995,13 @@
           <a:p>
             <a:pPr algn="ctr"/>
             <a:r>
-              <a:rPr sz="1500" b="1" i="0">
+              <a:rPr sz="1500" b="0" i="0">
                 <a:solidFill>
                   <a:srgbClr val="1F2A44"/>
                 </a:solidFill>
                 <a:latin typeface="Playfair Display"/>
               </a:rPr>
-              <a:t>4</a:t>
+              <a:t>30</a:t>
             </a:r>
           </a:p>
         </p:txBody>
@@ -3999,7 +4014,7 @@
         </p:nvSpPr>
         <p:spPr>
           <a:xfrm>
-            <a:off x="1522214" y="5044232"/>
+            <a:off x="5162996" y="5034707"/>
             <a:ext cx="874216" cy="592931"/>
           </a:xfrm>
           <a:prstGeom prst="rect">
@@ -4021,7 +4036,7 @@
                 </a:solidFill>
                 <a:latin typeface="Playfair Display"/>
               </a:rPr>
-              <a:t>4</a:t>
+              <a:t>26</a:t>
             </a:r>
           </a:p>
         </p:txBody>
@@ -4034,8 +4049,8 @@
         </p:nvSpPr>
         <p:spPr>
           <a:xfrm>
-            <a:off x="2396430" y="5044232"/>
-            <a:ext cx="874216" cy="592931"/>
+            <a:off x="6037213" y="5034707"/>
+            <a:ext cx="874663" cy="592931"/>
           </a:xfrm>
           <a:prstGeom prst="rect">
             <a:avLst/>
@@ -4056,111 +4071,6 @@
                 </a:solidFill>
                 <a:latin typeface="Playfair Display"/>
               </a:rPr>
-              <a:t>0</a:t>
-            </a:r>
-          </a:p>
-        </p:txBody>
-      </p:sp>
-      <p:sp>
-        <p:nvSpPr>
-          <p:cNvPr id="31" name="TextBox 30"/>
-          <p:cNvSpPr txBox="1"/>
-          <p:nvPr/>
-        </p:nvSpPr>
-        <p:spPr>
-          <a:xfrm>
-            <a:off x="3270647" y="5044232"/>
-            <a:ext cx="874216" cy="592931"/>
-          </a:xfrm>
-          <a:prstGeom prst="rect">
-            <a:avLst/>
-          </a:prstGeom>
-          <a:noFill/>
-        </p:spPr>
-        <p:txBody>
-          <a:bodyPr wrap="none" lIns="0" rIns="0" tIns="0" bIns="0" anchor="ctr">
-            <a:spAutoFit/>
-          </a:bodyPr>
-          <a:lstStyle/>
-          <a:p>
-            <a:pPr algn="ctr"/>
-            <a:r>
-              <a:rPr sz="1500" b="0" i="0">
-                <a:solidFill>
-                  <a:srgbClr val="1F2A44"/>
-                </a:solidFill>
-                <a:latin typeface="Playfair Display"/>
-              </a:rPr>
-              <a:t>30</a:t>
-            </a:r>
-          </a:p>
-        </p:txBody>
-      </p:sp>
-      <p:sp>
-        <p:nvSpPr>
-          <p:cNvPr id="32" name="TextBox 31"/>
-          <p:cNvSpPr txBox="1"/>
-          <p:nvPr/>
-        </p:nvSpPr>
-        <p:spPr>
-          <a:xfrm>
-            <a:off x="5162996" y="5044232"/>
-            <a:ext cx="874216" cy="592931"/>
-          </a:xfrm>
-          <a:prstGeom prst="rect">
-            <a:avLst/>
-          </a:prstGeom>
-          <a:noFill/>
-        </p:spPr>
-        <p:txBody>
-          <a:bodyPr wrap="none" lIns="0" rIns="0" tIns="0" bIns="0" anchor="ctr">
-            <a:spAutoFit/>
-          </a:bodyPr>
-          <a:lstStyle/>
-          <a:p>
-            <a:pPr algn="ctr"/>
-            <a:r>
-              <a:rPr sz="1500" b="0" i="0">
-                <a:solidFill>
-                  <a:srgbClr val="1F2A44"/>
-                </a:solidFill>
-                <a:latin typeface="Playfair Display"/>
-              </a:rPr>
-              <a:t>26</a:t>
-            </a:r>
-          </a:p>
-        </p:txBody>
-      </p:sp>
-      <p:sp>
-        <p:nvSpPr>
-          <p:cNvPr id="33" name="TextBox 32"/>
-          <p:cNvSpPr txBox="1"/>
-          <p:nvPr/>
-        </p:nvSpPr>
-        <p:spPr>
-          <a:xfrm>
-            <a:off x="6037213" y="5044232"/>
-            <a:ext cx="874663" cy="592931"/>
-          </a:xfrm>
-          <a:prstGeom prst="rect">
-            <a:avLst/>
-          </a:prstGeom>
-          <a:noFill/>
-        </p:spPr>
-        <p:txBody>
-          <a:bodyPr wrap="none" lIns="0" rIns="0" tIns="0" bIns="0" anchor="ctr">
-            <a:spAutoFit/>
-          </a:bodyPr>
-          <a:lstStyle/>
-          <a:p>
-            <a:pPr algn="ctr"/>
-            <a:r>
-              <a:rPr sz="1500" b="0" i="0">
-                <a:solidFill>
-                  <a:srgbClr val="1F2A44"/>
-                </a:solidFill>
-                <a:latin typeface="Playfair Display"/>
-              </a:rPr>
               <a:t>S</a:t>
             </a:r>
           </a:p>
@@ -4168,13 +4078,13 @@
       </p:sp>
       <p:sp>
         <p:nvSpPr>
-          <p:cNvPr id="34" name="Rectangle 33"/>
+          <p:cNvPr id="31" name="Rectangle 30"/>
           <p:cNvSpPr/>
           <p:nvPr/>
         </p:nvSpPr>
         <p:spPr>
           <a:xfrm>
-            <a:off x="647998" y="5637163"/>
+            <a:off x="647998" y="5627638"/>
             <a:ext cx="3496866" cy="597694"/>
           </a:xfrm>
           <a:prstGeom prst="rect">
@@ -4198,13 +4108,13 @@
       </p:sp>
       <p:sp>
         <p:nvSpPr>
-          <p:cNvPr id="35" name="Rectangle 34"/>
+          <p:cNvPr id="32" name="Rectangle 31"/>
           <p:cNvSpPr/>
           <p:nvPr/>
         </p:nvSpPr>
         <p:spPr>
           <a:xfrm>
-            <a:off x="647998" y="6227713"/>
+            <a:off x="647998" y="6218188"/>
             <a:ext cx="3496866" cy="7144"/>
           </a:xfrm>
           <a:prstGeom prst="rect">
@@ -4228,13 +4138,13 @@
       </p:sp>
       <p:sp>
         <p:nvSpPr>
-          <p:cNvPr id="36" name="Rectangle 35"/>
+          <p:cNvPr id="33" name="Rectangle 32"/>
           <p:cNvSpPr/>
           <p:nvPr/>
         </p:nvSpPr>
         <p:spPr>
           <a:xfrm>
-            <a:off x="4288780" y="5637163"/>
+            <a:off x="4288780" y="5627638"/>
             <a:ext cx="2623096" cy="597694"/>
           </a:xfrm>
           <a:prstGeom prst="rect">
@@ -4258,13 +4168,13 @@
       </p:sp>
       <p:sp>
         <p:nvSpPr>
-          <p:cNvPr id="37" name="Rectangle 36"/>
+          <p:cNvPr id="34" name="Rectangle 33"/>
           <p:cNvSpPr/>
           <p:nvPr/>
         </p:nvSpPr>
         <p:spPr>
           <a:xfrm>
-            <a:off x="4288780" y="6227713"/>
+            <a:off x="4288780" y="6218188"/>
             <a:ext cx="2623096" cy="7144"/>
           </a:xfrm>
           <a:prstGeom prst="rect">
@@ -4288,13 +4198,118 @@
       </p:sp>
       <p:sp>
         <p:nvSpPr>
+          <p:cNvPr id="35" name="TextBox 34"/>
+          <p:cNvSpPr txBox="1"/>
+          <p:nvPr/>
+        </p:nvSpPr>
+        <p:spPr>
+          <a:xfrm>
+            <a:off x="647998" y="5627638"/>
+            <a:ext cx="874216" cy="597694"/>
+          </a:xfrm>
+          <a:prstGeom prst="rect">
+            <a:avLst/>
+          </a:prstGeom>
+          <a:noFill/>
+        </p:spPr>
+        <p:txBody>
+          <a:bodyPr wrap="none" lIns="0" rIns="0" tIns="0" bIns="0" anchor="ctr">
+            <a:spAutoFit/>
+          </a:bodyPr>
+          <a:lstStyle/>
+          <a:p>
+            <a:pPr algn="ctr"/>
+            <a:r>
+              <a:rPr sz="1500" b="1" i="0">
+                <a:solidFill>
+                  <a:srgbClr val="1F2A44"/>
+                </a:solidFill>
+                <a:latin typeface="Playfair Display"/>
+              </a:rPr>
+              <a:t>6</a:t>
+            </a:r>
+          </a:p>
+        </p:txBody>
+      </p:sp>
+      <p:sp>
+        <p:nvSpPr>
+          <p:cNvPr id="36" name="TextBox 35"/>
+          <p:cNvSpPr txBox="1"/>
+          <p:nvPr/>
+        </p:nvSpPr>
+        <p:spPr>
+          <a:xfrm>
+            <a:off x="1522214" y="5627638"/>
+            <a:ext cx="874216" cy="597694"/>
+          </a:xfrm>
+          <a:prstGeom prst="rect">
+            <a:avLst/>
+          </a:prstGeom>
+          <a:noFill/>
+        </p:spPr>
+        <p:txBody>
+          <a:bodyPr wrap="none" lIns="0" rIns="0" tIns="0" bIns="0" anchor="ctr">
+            <a:spAutoFit/>
+          </a:bodyPr>
+          <a:lstStyle/>
+          <a:p>
+            <a:pPr algn="ctr"/>
+            <a:r>
+              <a:rPr sz="1500" b="0" i="0">
+                <a:solidFill>
+                  <a:srgbClr val="1F2A44"/>
+                </a:solidFill>
+                <a:latin typeface="Playfair Display"/>
+              </a:rPr>
+              <a:t>6</a:t>
+            </a:r>
+          </a:p>
+        </p:txBody>
+      </p:sp>
+      <p:sp>
+        <p:nvSpPr>
+          <p:cNvPr id="37" name="TextBox 36"/>
+          <p:cNvSpPr txBox="1"/>
+          <p:nvPr/>
+        </p:nvSpPr>
+        <p:spPr>
+          <a:xfrm>
+            <a:off x="2396430" y="5627638"/>
+            <a:ext cx="874216" cy="597694"/>
+          </a:xfrm>
+          <a:prstGeom prst="rect">
+            <a:avLst/>
+          </a:prstGeom>
+          <a:noFill/>
+        </p:spPr>
+        <p:txBody>
+          <a:bodyPr wrap="none" lIns="0" rIns="0" tIns="0" bIns="0" anchor="ctr">
+            <a:spAutoFit/>
+          </a:bodyPr>
+          <a:lstStyle/>
+          <a:p>
+            <a:pPr algn="ctr"/>
+            <a:r>
+              <a:rPr sz="1500" b="0" i="0">
+                <a:solidFill>
+                  <a:srgbClr val="1F2A44"/>
+                </a:solidFill>
+                <a:latin typeface="Playfair Display"/>
+              </a:rPr>
+              <a:t>2</a:t>
+            </a:r>
+          </a:p>
+        </p:txBody>
+      </p:sp>
+      <p:sp>
+        <p:nvSpPr>
           <p:cNvPr id="38" name="TextBox 37"/>
           <p:cNvSpPr txBox="1"/>
           <p:nvPr/>
         </p:nvSpPr>
         <p:spPr>
           <a:xfrm>
-            <a:off x="647998" y="5637163"/>
+            <a:off x="3270647" y="5627638"/>
             <a:ext cx="874216" cy="597694"/>
           </a:xfrm>
           <a:prstGeom prst="rect">
@@ -4310,13 +4325,13 @@
           <a:p>
             <a:pPr algn="ctr"/>
             <a:r>
-              <a:rPr sz="1500" b="1" i="0">
+              <a:rPr sz="1500" b="0" i="0">
                 <a:solidFill>
                   <a:srgbClr val="1F2A44"/>
                 </a:solidFill>
                 <a:latin typeface="Playfair Display"/>
               </a:rPr>
-              <a:t>6</a:t>
+              <a:t>32</a:t>
             </a:r>
           </a:p>
         </p:txBody>
@@ -4329,7 +4344,7 @@
         </p:nvSpPr>
         <p:spPr>
           <a:xfrm>
-            <a:off x="1522214" y="5637163"/>
+            <a:off x="4288780" y="5627638"/>
             <a:ext cx="874216" cy="597694"/>
           </a:xfrm>
           <a:prstGeom prst="rect">
@@ -4351,7 +4366,7 @@
                 </a:solidFill>
                 <a:latin typeface="Playfair Display"/>
               </a:rPr>
-              <a:t>6</a:t>
+              <a:t>34</a:t>
             </a:r>
           </a:p>
         </p:txBody>
@@ -4364,7 +4379,7 @@
         </p:nvSpPr>
         <p:spPr>
           <a:xfrm>
-            <a:off x="2396430" y="5637163"/>
+            <a:off x="5162996" y="5627638"/>
             <a:ext cx="874216" cy="597694"/>
           </a:xfrm>
           <a:prstGeom prst="rect">
@@ -4386,7 +4401,7 @@
                 </a:solidFill>
                 <a:latin typeface="Playfair Display"/>
               </a:rPr>
-              <a:t>2</a:t>
+              <a:t>27</a:t>
             </a:r>
           </a:p>
         </p:txBody>
@@ -4399,8 +4414,8 @@
         </p:nvSpPr>
         <p:spPr>
           <a:xfrm>
-            <a:off x="3270647" y="5637163"/>
-            <a:ext cx="874216" cy="597694"/>
+            <a:off x="6037213" y="5627638"/>
+            <a:ext cx="874663" cy="597694"/>
           </a:xfrm>
           <a:prstGeom prst="rect">
             <a:avLst/>
@@ -4421,111 +4436,6 @@
                 </a:solidFill>
                 <a:latin typeface="Playfair Display"/>
               </a:rPr>
-              <a:t>32</a:t>
-            </a:r>
-          </a:p>
-        </p:txBody>
-      </p:sp>
-      <p:sp>
-        <p:nvSpPr>
-          <p:cNvPr id="42" name="TextBox 41"/>
-          <p:cNvSpPr txBox="1"/>
-          <p:nvPr/>
-        </p:nvSpPr>
-        <p:spPr>
-          <a:xfrm>
-            <a:off x="4288780" y="5637163"/>
-            <a:ext cx="874216" cy="597694"/>
-          </a:xfrm>
-          <a:prstGeom prst="rect">
-            <a:avLst/>
-          </a:prstGeom>
-          <a:noFill/>
-        </p:spPr>
-        <p:txBody>
-          <a:bodyPr wrap="none" lIns="0" rIns="0" tIns="0" bIns="0" anchor="ctr">
-            <a:spAutoFit/>
-          </a:bodyPr>
-          <a:lstStyle/>
-          <a:p>
-            <a:pPr algn="ctr"/>
-            <a:r>
-              <a:rPr sz="1500" b="0" i="0">
-                <a:solidFill>
-                  <a:srgbClr val="1F2A44"/>
-                </a:solidFill>
-                <a:latin typeface="Playfair Display"/>
-              </a:rPr>
-              <a:t>34</a:t>
-            </a:r>
-          </a:p>
-        </p:txBody>
-      </p:sp>
-      <p:sp>
-        <p:nvSpPr>
-          <p:cNvPr id="43" name="TextBox 42"/>
-          <p:cNvSpPr txBox="1"/>
-          <p:nvPr/>
-        </p:nvSpPr>
-        <p:spPr>
-          <a:xfrm>
-            <a:off x="5162996" y="5637163"/>
-            <a:ext cx="874216" cy="597694"/>
-          </a:xfrm>
-          <a:prstGeom prst="rect">
-            <a:avLst/>
-          </a:prstGeom>
-          <a:noFill/>
-        </p:spPr>
-        <p:txBody>
-          <a:bodyPr wrap="none" lIns="0" rIns="0" tIns="0" bIns="0" anchor="ctr">
-            <a:spAutoFit/>
-          </a:bodyPr>
-          <a:lstStyle/>
-          <a:p>
-            <a:pPr algn="ctr"/>
-            <a:r>
-              <a:rPr sz="1500" b="0" i="0">
-                <a:solidFill>
-                  <a:srgbClr val="1F2A44"/>
-                </a:solidFill>
-                <a:latin typeface="Playfair Display"/>
-              </a:rPr>
-              <a:t>27</a:t>
-            </a:r>
-          </a:p>
-        </p:txBody>
-      </p:sp>
-      <p:sp>
-        <p:nvSpPr>
-          <p:cNvPr id="44" name="TextBox 43"/>
-          <p:cNvSpPr txBox="1"/>
-          <p:nvPr/>
-        </p:nvSpPr>
-        <p:spPr>
-          <a:xfrm>
-            <a:off x="6037213" y="5637163"/>
-            <a:ext cx="874663" cy="597694"/>
-          </a:xfrm>
-          <a:prstGeom prst="rect">
-            <a:avLst/>
-          </a:prstGeom>
-          <a:noFill/>
-        </p:spPr>
-        <p:txBody>
-          <a:bodyPr wrap="none" lIns="0" rIns="0" tIns="0" bIns="0" anchor="ctr">
-            <a:spAutoFit/>
-          </a:bodyPr>
-          <a:lstStyle/>
-          <a:p>
-            <a:pPr algn="ctr"/>
-            <a:r>
-              <a:rPr sz="1500" b="0" i="0">
-                <a:solidFill>
-                  <a:srgbClr val="1F2A44"/>
-                </a:solidFill>
-                <a:latin typeface="Playfair Display"/>
-              </a:rPr>
               <a:t>S</a:t>
             </a:r>
           </a:p>
@@ -4533,13 +4443,13 @@
       </p:sp>
       <p:sp>
         <p:nvSpPr>
-          <p:cNvPr id="45" name="Rectangle 44"/>
+          <p:cNvPr id="42" name="Rectangle 41"/>
           <p:cNvSpPr/>
           <p:nvPr/>
         </p:nvSpPr>
         <p:spPr>
           <a:xfrm>
-            <a:off x="647998" y="6825407"/>
+            <a:off x="647998" y="6815882"/>
             <a:ext cx="3496866" cy="7144"/>
           </a:xfrm>
           <a:prstGeom prst="rect">
@@ -4563,13 +4473,13 @@
       </p:sp>
       <p:sp>
         <p:nvSpPr>
-          <p:cNvPr id="46" name="Rectangle 45"/>
+          <p:cNvPr id="43" name="Rectangle 42"/>
           <p:cNvSpPr/>
           <p:nvPr/>
         </p:nvSpPr>
         <p:spPr>
           <a:xfrm>
-            <a:off x="4288780" y="6825407"/>
+            <a:off x="4288780" y="6815882"/>
             <a:ext cx="2623096" cy="7144"/>
           </a:xfrm>
           <a:prstGeom prst="rect">
@@ -4593,13 +4503,118 @@
       </p:sp>
       <p:sp>
         <p:nvSpPr>
+          <p:cNvPr id="44" name="TextBox 43"/>
+          <p:cNvSpPr txBox="1"/>
+          <p:nvPr/>
+        </p:nvSpPr>
+        <p:spPr>
+          <a:xfrm>
+            <a:off x="647998" y="6225332"/>
+            <a:ext cx="874216" cy="597694"/>
+          </a:xfrm>
+          <a:prstGeom prst="rect">
+            <a:avLst/>
+          </a:prstGeom>
+          <a:noFill/>
+        </p:spPr>
+        <p:txBody>
+          <a:bodyPr wrap="none" lIns="0" rIns="0" tIns="0" bIns="0" anchor="ctr">
+            <a:spAutoFit/>
+          </a:bodyPr>
+          <a:lstStyle/>
+          <a:p>
+            <a:pPr algn="ctr"/>
+            <a:r>
+              <a:rPr sz="1500" b="1" i="0">
+                <a:solidFill>
+                  <a:srgbClr val="1F2A44"/>
+                </a:solidFill>
+                <a:latin typeface="Playfair Display"/>
+              </a:rPr>
+              <a:t>8</a:t>
+            </a:r>
+          </a:p>
+        </p:txBody>
+      </p:sp>
+      <p:sp>
+        <p:nvSpPr>
+          <p:cNvPr id="45" name="TextBox 44"/>
+          <p:cNvSpPr txBox="1"/>
+          <p:nvPr/>
+        </p:nvSpPr>
+        <p:spPr>
+          <a:xfrm>
+            <a:off x="1522214" y="6225332"/>
+            <a:ext cx="874216" cy="597694"/>
+          </a:xfrm>
+          <a:prstGeom prst="rect">
+            <a:avLst/>
+          </a:prstGeom>
+          <a:noFill/>
+        </p:spPr>
+        <p:txBody>
+          <a:bodyPr wrap="none" lIns="0" rIns="0" tIns="0" bIns="0" anchor="ctr">
+            <a:spAutoFit/>
+          </a:bodyPr>
+          <a:lstStyle/>
+          <a:p>
+            <a:pPr algn="ctr"/>
+            <a:r>
+              <a:rPr sz="1500" b="0" i="0">
+                <a:solidFill>
+                  <a:srgbClr val="1F2A44"/>
+                </a:solidFill>
+                <a:latin typeface="Playfair Display"/>
+              </a:rPr>
+              <a:t>8</a:t>
+            </a:r>
+          </a:p>
+        </p:txBody>
+      </p:sp>
+      <p:sp>
+        <p:nvSpPr>
+          <p:cNvPr id="46" name="TextBox 45"/>
+          <p:cNvSpPr txBox="1"/>
+          <p:nvPr/>
+        </p:nvSpPr>
+        <p:spPr>
+          <a:xfrm>
+            <a:off x="2396430" y="6225332"/>
+            <a:ext cx="874216" cy="597694"/>
+          </a:xfrm>
+          <a:prstGeom prst="rect">
+            <a:avLst/>
+          </a:prstGeom>
+          <a:noFill/>
+        </p:spPr>
+        <p:txBody>
+          <a:bodyPr wrap="none" lIns="0" rIns="0" tIns="0" bIns="0" anchor="ctr">
+            <a:spAutoFit/>
+          </a:bodyPr>
+          <a:lstStyle/>
+          <a:p>
+            <a:pPr algn="ctr"/>
+            <a:r>
+              <a:rPr sz="1500" b="0" i="0">
+                <a:solidFill>
+                  <a:srgbClr val="1F2A44"/>
+                </a:solidFill>
+                <a:latin typeface="Playfair Display"/>
+              </a:rPr>
+              <a:t>4</a:t>
+            </a:r>
+          </a:p>
+        </p:txBody>
+      </p:sp>
+      <p:sp>
+        <p:nvSpPr>
           <p:cNvPr id="47" name="TextBox 46"/>
           <p:cNvSpPr txBox="1"/>
           <p:nvPr/>
         </p:nvSpPr>
         <p:spPr>
           <a:xfrm>
-            <a:off x="647998" y="6234857"/>
+            <a:off x="3270647" y="6225332"/>
             <a:ext cx="874216" cy="597694"/>
           </a:xfrm>
           <a:prstGeom prst="rect">
@@ -4615,13 +4630,13 @@
           <a:p>
             <a:pPr algn="ctr"/>
             <a:r>
-              <a:rPr sz="1500" b="1" i="0">
+              <a:rPr sz="1500" b="0" i="0">
                 <a:solidFill>
                   <a:srgbClr val="1F2A44"/>
                 </a:solidFill>
                 <a:latin typeface="Playfair Display"/>
               </a:rPr>
-              <a:t>8</a:t>
+              <a:t>34</a:t>
             </a:r>
           </a:p>
         </p:txBody>
@@ -4634,7 +4649,7 @@
         </p:nvSpPr>
         <p:spPr>
           <a:xfrm>
-            <a:off x="1522214" y="6234857"/>
+            <a:off x="4288780" y="6225332"/>
             <a:ext cx="874216" cy="597694"/>
           </a:xfrm>
           <a:prstGeom prst="rect">
@@ -4656,7 +4671,7 @@
                 </a:solidFill>
                 <a:latin typeface="Playfair Display"/>
               </a:rPr>
-              <a:t>8</a:t>
+              <a:t>36</a:t>
             </a:r>
           </a:p>
         </p:txBody>
@@ -4669,7 +4684,7 @@
         </p:nvSpPr>
         <p:spPr>
           <a:xfrm>
-            <a:off x="2396430" y="6234857"/>
+            <a:off x="5162996" y="6225332"/>
             <a:ext cx="874216" cy="597694"/>
           </a:xfrm>
           <a:prstGeom prst="rect">
@@ -4691,7 +4706,7 @@
                 </a:solidFill>
                 <a:latin typeface="Playfair Display"/>
               </a:rPr>
-              <a:t>4</a:t>
+              <a:t>28</a:t>
             </a:r>
           </a:p>
         </p:txBody>
@@ -4704,8 +4719,8 @@
         </p:nvSpPr>
         <p:spPr>
           <a:xfrm>
-            <a:off x="3270647" y="6234857"/>
-            <a:ext cx="874216" cy="597694"/>
+            <a:off x="6037213" y="6225332"/>
+            <a:ext cx="874663" cy="597694"/>
           </a:xfrm>
           <a:prstGeom prst="rect">
             <a:avLst/>
@@ -4726,111 +4741,6 @@
                 </a:solidFill>
                 <a:latin typeface="Playfair Display"/>
               </a:rPr>
-              <a:t>34</a:t>
-            </a:r>
-          </a:p>
-        </p:txBody>
-      </p:sp>
-      <p:sp>
-        <p:nvSpPr>
-          <p:cNvPr id="51" name="TextBox 50"/>
-          <p:cNvSpPr txBox="1"/>
-          <p:nvPr/>
-        </p:nvSpPr>
-        <p:spPr>
-          <a:xfrm>
-            <a:off x="4288780" y="6234857"/>
-            <a:ext cx="874216" cy="597694"/>
-          </a:xfrm>
-          <a:prstGeom prst="rect">
-            <a:avLst/>
-          </a:prstGeom>
-          <a:noFill/>
-        </p:spPr>
-        <p:txBody>
-          <a:bodyPr wrap="none" lIns="0" rIns="0" tIns="0" bIns="0" anchor="ctr">
-            <a:spAutoFit/>
-          </a:bodyPr>
-          <a:lstStyle/>
-          <a:p>
-            <a:pPr algn="ctr"/>
-            <a:r>
-              <a:rPr sz="1500" b="0" i="0">
-                <a:solidFill>
-                  <a:srgbClr val="1F2A44"/>
-                </a:solidFill>
-                <a:latin typeface="Playfair Display"/>
-              </a:rPr>
-              <a:t>36</a:t>
-            </a:r>
-          </a:p>
-        </p:txBody>
-      </p:sp>
-      <p:sp>
-        <p:nvSpPr>
-          <p:cNvPr id="52" name="TextBox 51"/>
-          <p:cNvSpPr txBox="1"/>
-          <p:nvPr/>
-        </p:nvSpPr>
-        <p:spPr>
-          <a:xfrm>
-            <a:off x="5162996" y="6234857"/>
-            <a:ext cx="874216" cy="597694"/>
-          </a:xfrm>
-          <a:prstGeom prst="rect">
-            <a:avLst/>
-          </a:prstGeom>
-          <a:noFill/>
-        </p:spPr>
-        <p:txBody>
-          <a:bodyPr wrap="none" lIns="0" rIns="0" tIns="0" bIns="0" anchor="ctr">
-            <a:spAutoFit/>
-          </a:bodyPr>
-          <a:lstStyle/>
-          <a:p>
-            <a:pPr algn="ctr"/>
-            <a:r>
-              <a:rPr sz="1500" b="0" i="0">
-                <a:solidFill>
-                  <a:srgbClr val="1F2A44"/>
-                </a:solidFill>
-                <a:latin typeface="Playfair Display"/>
-              </a:rPr>
-              <a:t>28</a:t>
-            </a:r>
-          </a:p>
-        </p:txBody>
-      </p:sp>
-      <p:sp>
-        <p:nvSpPr>
-          <p:cNvPr id="53" name="TextBox 52"/>
-          <p:cNvSpPr txBox="1"/>
-          <p:nvPr/>
-        </p:nvSpPr>
-        <p:spPr>
-          <a:xfrm>
-            <a:off x="6037213" y="6234857"/>
-            <a:ext cx="874663" cy="597694"/>
-          </a:xfrm>
-          <a:prstGeom prst="rect">
-            <a:avLst/>
-          </a:prstGeom>
-          <a:noFill/>
-        </p:spPr>
-        <p:txBody>
-          <a:bodyPr wrap="none" lIns="0" rIns="0" tIns="0" bIns="0" anchor="ctr">
-            <a:spAutoFit/>
-          </a:bodyPr>
-          <a:lstStyle/>
-          <a:p>
-            <a:pPr algn="ctr"/>
-            <a:r>
-              <a:rPr sz="1500" b="0" i="0">
-                <a:solidFill>
-                  <a:srgbClr val="1F2A44"/>
-                </a:solidFill>
-                <a:latin typeface="Playfair Display"/>
-              </a:rPr>
               <a:t>M</a:t>
             </a:r>
           </a:p>
@@ -4838,13 +4748,13 @@
       </p:sp>
       <p:sp>
         <p:nvSpPr>
-          <p:cNvPr id="54" name="Rectangle 53"/>
+          <p:cNvPr id="51" name="Rectangle 50"/>
           <p:cNvSpPr/>
           <p:nvPr/>
         </p:nvSpPr>
         <p:spPr>
           <a:xfrm>
-            <a:off x="647998" y="6832550"/>
+            <a:off x="647998" y="6823025"/>
             <a:ext cx="3496866" cy="597694"/>
           </a:xfrm>
           <a:prstGeom prst="rect">
@@ -4868,13 +4778,13 @@
       </p:sp>
       <p:sp>
         <p:nvSpPr>
-          <p:cNvPr id="55" name="Rectangle 54"/>
+          <p:cNvPr id="52" name="Rectangle 51"/>
           <p:cNvSpPr/>
           <p:nvPr/>
         </p:nvSpPr>
         <p:spPr>
           <a:xfrm>
-            <a:off x="647998" y="7423100"/>
+            <a:off x="647998" y="7413575"/>
             <a:ext cx="3496866" cy="7144"/>
           </a:xfrm>
           <a:prstGeom prst="rect">
@@ -4898,13 +4808,13 @@
       </p:sp>
       <p:sp>
         <p:nvSpPr>
-          <p:cNvPr id="56" name="Rectangle 55"/>
+          <p:cNvPr id="53" name="Rectangle 52"/>
           <p:cNvSpPr/>
           <p:nvPr/>
         </p:nvSpPr>
         <p:spPr>
           <a:xfrm>
-            <a:off x="4288780" y="6832550"/>
+            <a:off x="4288780" y="6823025"/>
             <a:ext cx="2623096" cy="597694"/>
           </a:xfrm>
           <a:prstGeom prst="rect">
@@ -4928,13 +4838,13 @@
       </p:sp>
       <p:sp>
         <p:nvSpPr>
-          <p:cNvPr id="57" name="Rectangle 56"/>
+          <p:cNvPr id="54" name="Rectangle 53"/>
           <p:cNvSpPr/>
           <p:nvPr/>
         </p:nvSpPr>
         <p:spPr>
           <a:xfrm>
-            <a:off x="4288780" y="7423100"/>
+            <a:off x="4288780" y="7413575"/>
             <a:ext cx="2623096" cy="7144"/>
           </a:xfrm>
           <a:prstGeom prst="rect">
@@ -4958,13 +4868,118 @@
       </p:sp>
       <p:sp>
         <p:nvSpPr>
+          <p:cNvPr id="55" name="TextBox 54"/>
+          <p:cNvSpPr txBox="1"/>
+          <p:nvPr/>
+        </p:nvSpPr>
+        <p:spPr>
+          <a:xfrm>
+            <a:off x="647998" y="6823025"/>
+            <a:ext cx="874216" cy="597694"/>
+          </a:xfrm>
+          <a:prstGeom prst="rect">
+            <a:avLst/>
+          </a:prstGeom>
+          <a:noFill/>
+        </p:spPr>
+        <p:txBody>
+          <a:bodyPr wrap="none" lIns="0" rIns="0" tIns="0" bIns="0" anchor="ctr">
+            <a:spAutoFit/>
+          </a:bodyPr>
+          <a:lstStyle/>
+          <a:p>
+            <a:pPr algn="ctr"/>
+            <a:r>
+              <a:rPr sz="1500" b="1" i="0">
+                <a:solidFill>
+                  <a:srgbClr val="1F2A44"/>
+                </a:solidFill>
+                <a:latin typeface="Playfair Display"/>
+              </a:rPr>
+              <a:t>10</a:t>
+            </a:r>
+          </a:p>
+        </p:txBody>
+      </p:sp>
+      <p:sp>
+        <p:nvSpPr>
+          <p:cNvPr id="56" name="TextBox 55"/>
+          <p:cNvSpPr txBox="1"/>
+          <p:nvPr/>
+        </p:nvSpPr>
+        <p:spPr>
+          <a:xfrm>
+            <a:off x="1522214" y="6823025"/>
+            <a:ext cx="874216" cy="597694"/>
+          </a:xfrm>
+          <a:prstGeom prst="rect">
+            <a:avLst/>
+          </a:prstGeom>
+          <a:noFill/>
+        </p:spPr>
+        <p:txBody>
+          <a:bodyPr wrap="none" lIns="0" rIns="0" tIns="0" bIns="0" anchor="ctr">
+            <a:spAutoFit/>
+          </a:bodyPr>
+          <a:lstStyle/>
+          <a:p>
+            <a:pPr algn="ctr"/>
+            <a:r>
+              <a:rPr sz="1500" b="0" i="0">
+                <a:solidFill>
+                  <a:srgbClr val="1F2A44"/>
+                </a:solidFill>
+                <a:latin typeface="Playfair Display"/>
+              </a:rPr>
+              <a:t>10</a:t>
+            </a:r>
+          </a:p>
+        </p:txBody>
+      </p:sp>
+      <p:sp>
+        <p:nvSpPr>
+          <p:cNvPr id="57" name="TextBox 56"/>
+          <p:cNvSpPr txBox="1"/>
+          <p:nvPr/>
+        </p:nvSpPr>
+        <p:spPr>
+          <a:xfrm>
+            <a:off x="2396430" y="6823025"/>
+            <a:ext cx="874216" cy="597694"/>
+          </a:xfrm>
+          <a:prstGeom prst="rect">
+            <a:avLst/>
+          </a:prstGeom>
+          <a:noFill/>
+        </p:spPr>
+        <p:txBody>
+          <a:bodyPr wrap="none" lIns="0" rIns="0" tIns="0" bIns="0" anchor="ctr">
+            <a:spAutoFit/>
+          </a:bodyPr>
+          <a:lstStyle/>
+          <a:p>
+            <a:pPr algn="ctr"/>
+            <a:r>
+              <a:rPr sz="1500" b="0" i="0">
+                <a:solidFill>
+                  <a:srgbClr val="1F2A44"/>
+                </a:solidFill>
+                <a:latin typeface="Playfair Display"/>
+              </a:rPr>
+              <a:t>6</a:t>
+            </a:r>
+          </a:p>
+        </p:txBody>
+      </p:sp>
+      <p:sp>
+        <p:nvSpPr>
           <p:cNvPr id="58" name="TextBox 57"/>
           <p:cNvSpPr txBox="1"/>
           <p:nvPr/>
         </p:nvSpPr>
         <p:spPr>
           <a:xfrm>
-            <a:off x="647998" y="6832550"/>
+            <a:off x="3270647" y="6823025"/>
             <a:ext cx="874216" cy="597694"/>
           </a:xfrm>
           <a:prstGeom prst="rect">
@@ -4980,13 +4995,13 @@
           <a:p>
             <a:pPr algn="ctr"/>
             <a:r>
-              <a:rPr sz="1500" b="1" i="0">
+              <a:rPr sz="1500" b="0" i="0">
                 <a:solidFill>
                   <a:srgbClr val="1F2A44"/>
                 </a:solidFill>
                 <a:latin typeface="Playfair Display"/>
               </a:rPr>
-              <a:t>10</a:t>
+              <a:t>36</a:t>
             </a:r>
           </a:p>
         </p:txBody>
@@ -4999,7 +5014,7 @@
         </p:nvSpPr>
         <p:spPr>
           <a:xfrm>
-            <a:off x="1522214" y="6832550"/>
+            <a:off x="4288780" y="6823025"/>
             <a:ext cx="874216" cy="597694"/>
           </a:xfrm>
           <a:prstGeom prst="rect">
@@ -5021,7 +5036,7 @@
                 </a:solidFill>
                 <a:latin typeface="Playfair Display"/>
               </a:rPr>
-              <a:t>10</a:t>
+              <a:t>38</a:t>
             </a:r>
           </a:p>
         </p:txBody>
@@ -5034,7 +5049,7 @@
         </p:nvSpPr>
         <p:spPr>
           <a:xfrm>
-            <a:off x="2396430" y="6832550"/>
+            <a:off x="5162996" y="6823025"/>
             <a:ext cx="874216" cy="597694"/>
           </a:xfrm>
           <a:prstGeom prst="rect">
@@ -5056,7 +5071,7 @@
                 </a:solidFill>
                 <a:latin typeface="Playfair Display"/>
               </a:rPr>
-              <a:t>6</a:t>
+              <a:t>29</a:t>
             </a:r>
           </a:p>
         </p:txBody>
@@ -5069,8 +5084,8 @@
         </p:nvSpPr>
         <p:spPr>
           <a:xfrm>
-            <a:off x="3270647" y="6832550"/>
-            <a:ext cx="874216" cy="597694"/>
+            <a:off x="6037213" y="6823025"/>
+            <a:ext cx="874663" cy="597694"/>
           </a:xfrm>
           <a:prstGeom prst="rect">
             <a:avLst/>
@@ -5091,111 +5106,6 @@
                 </a:solidFill>
                 <a:latin typeface="Playfair Display"/>
               </a:rPr>
-              <a:t>36</a:t>
-            </a:r>
-          </a:p>
-        </p:txBody>
-      </p:sp>
-      <p:sp>
-        <p:nvSpPr>
-          <p:cNvPr id="62" name="TextBox 61"/>
-          <p:cNvSpPr txBox="1"/>
-          <p:nvPr/>
-        </p:nvSpPr>
-        <p:spPr>
-          <a:xfrm>
-            <a:off x="4288780" y="6832550"/>
-            <a:ext cx="874216" cy="597694"/>
-          </a:xfrm>
-          <a:prstGeom prst="rect">
-            <a:avLst/>
-          </a:prstGeom>
-          <a:noFill/>
-        </p:spPr>
-        <p:txBody>
-          <a:bodyPr wrap="none" lIns="0" rIns="0" tIns="0" bIns="0" anchor="ctr">
-            <a:spAutoFit/>
-          </a:bodyPr>
-          <a:lstStyle/>
-          <a:p>
-            <a:pPr algn="ctr"/>
-            <a:r>
-              <a:rPr sz="1500" b="0" i="0">
-                <a:solidFill>
-                  <a:srgbClr val="1F2A44"/>
-                </a:solidFill>
-                <a:latin typeface="Playfair Display"/>
-              </a:rPr>
-              <a:t>38</a:t>
-            </a:r>
-          </a:p>
-        </p:txBody>
-      </p:sp>
-      <p:sp>
-        <p:nvSpPr>
-          <p:cNvPr id="63" name="TextBox 62"/>
-          <p:cNvSpPr txBox="1"/>
-          <p:nvPr/>
-        </p:nvSpPr>
-        <p:spPr>
-          <a:xfrm>
-            <a:off x="5162996" y="6832550"/>
-            <a:ext cx="874216" cy="597694"/>
-          </a:xfrm>
-          <a:prstGeom prst="rect">
-            <a:avLst/>
-          </a:prstGeom>
-          <a:noFill/>
-        </p:spPr>
-        <p:txBody>
-          <a:bodyPr wrap="none" lIns="0" rIns="0" tIns="0" bIns="0" anchor="ctr">
-            <a:spAutoFit/>
-          </a:bodyPr>
-          <a:lstStyle/>
-          <a:p>
-            <a:pPr algn="ctr"/>
-            <a:r>
-              <a:rPr sz="1500" b="0" i="0">
-                <a:solidFill>
-                  <a:srgbClr val="1F2A44"/>
-                </a:solidFill>
-                <a:latin typeface="Playfair Display"/>
-              </a:rPr>
-              <a:t>29</a:t>
-            </a:r>
-          </a:p>
-        </p:txBody>
-      </p:sp>
-      <p:sp>
-        <p:nvSpPr>
-          <p:cNvPr id="64" name="TextBox 63"/>
-          <p:cNvSpPr txBox="1"/>
-          <p:nvPr/>
-        </p:nvSpPr>
-        <p:spPr>
-          <a:xfrm>
-            <a:off x="6037213" y="6832550"/>
-            <a:ext cx="874663" cy="597694"/>
-          </a:xfrm>
-          <a:prstGeom prst="rect">
-            <a:avLst/>
-          </a:prstGeom>
-          <a:noFill/>
-        </p:spPr>
-        <p:txBody>
-          <a:bodyPr wrap="none" lIns="0" rIns="0" tIns="0" bIns="0" anchor="ctr">
-            <a:spAutoFit/>
-          </a:bodyPr>
-          <a:lstStyle/>
-          <a:p>
-            <a:pPr algn="ctr"/>
-            <a:r>
-              <a:rPr sz="1500" b="0" i="0">
-                <a:solidFill>
-                  <a:srgbClr val="1F2A44"/>
-                </a:solidFill>
-                <a:latin typeface="Playfair Display"/>
-              </a:rPr>
               <a:t>M</a:t>
             </a:r>
           </a:p>
@@ -5203,13 +5113,13 @@
       </p:sp>
       <p:sp>
         <p:nvSpPr>
-          <p:cNvPr id="65" name="Rectangle 64"/>
+          <p:cNvPr id="62" name="Rectangle 61"/>
           <p:cNvSpPr/>
           <p:nvPr/>
         </p:nvSpPr>
         <p:spPr>
           <a:xfrm>
-            <a:off x="647998" y="8020794"/>
+            <a:off x="647998" y="8011269"/>
             <a:ext cx="3496866" cy="7144"/>
           </a:xfrm>
           <a:prstGeom prst="rect">
@@ -5233,13 +5143,13 @@
       </p:sp>
       <p:sp>
         <p:nvSpPr>
-          <p:cNvPr id="66" name="Rectangle 65"/>
+          <p:cNvPr id="63" name="Rectangle 62"/>
           <p:cNvSpPr/>
           <p:nvPr/>
         </p:nvSpPr>
         <p:spPr>
           <a:xfrm>
-            <a:off x="4288780" y="8020794"/>
+            <a:off x="4288780" y="8011269"/>
             <a:ext cx="2623096" cy="7144"/>
           </a:xfrm>
           <a:prstGeom prst="rect">
@@ -5263,13 +5173,118 @@
       </p:sp>
       <p:sp>
         <p:nvSpPr>
+          <p:cNvPr id="64" name="TextBox 63"/>
+          <p:cNvSpPr txBox="1"/>
+          <p:nvPr/>
+        </p:nvSpPr>
+        <p:spPr>
+          <a:xfrm>
+            <a:off x="647998" y="7420719"/>
+            <a:ext cx="874216" cy="597694"/>
+          </a:xfrm>
+          <a:prstGeom prst="rect">
+            <a:avLst/>
+          </a:prstGeom>
+          <a:noFill/>
+        </p:spPr>
+        <p:txBody>
+          <a:bodyPr wrap="none" lIns="0" rIns="0" tIns="0" bIns="0" anchor="ctr">
+            <a:spAutoFit/>
+          </a:bodyPr>
+          <a:lstStyle/>
+          <a:p>
+            <a:pPr algn="ctr"/>
+            <a:r>
+              <a:rPr sz="1500" b="1" i="0">
+                <a:solidFill>
+                  <a:srgbClr val="1F2A44"/>
+                </a:solidFill>
+                <a:latin typeface="Playfair Display"/>
+              </a:rPr>
+              <a:t>12</a:t>
+            </a:r>
+          </a:p>
+        </p:txBody>
+      </p:sp>
+      <p:sp>
+        <p:nvSpPr>
+          <p:cNvPr id="65" name="TextBox 64"/>
+          <p:cNvSpPr txBox="1"/>
+          <p:nvPr/>
+        </p:nvSpPr>
+        <p:spPr>
+          <a:xfrm>
+            <a:off x="1522214" y="7420719"/>
+            <a:ext cx="874216" cy="597694"/>
+          </a:xfrm>
+          <a:prstGeom prst="rect">
+            <a:avLst/>
+          </a:prstGeom>
+          <a:noFill/>
+        </p:spPr>
+        <p:txBody>
+          <a:bodyPr wrap="none" lIns="0" rIns="0" tIns="0" bIns="0" anchor="ctr">
+            <a:spAutoFit/>
+          </a:bodyPr>
+          <a:lstStyle/>
+          <a:p>
+            <a:pPr algn="ctr"/>
+            <a:r>
+              <a:rPr sz="1500" b="0" i="0">
+                <a:solidFill>
+                  <a:srgbClr val="1F2A44"/>
+                </a:solidFill>
+                <a:latin typeface="Playfair Display"/>
+              </a:rPr>
+              <a:t>12</a:t>
+            </a:r>
+          </a:p>
+        </p:txBody>
+      </p:sp>
+      <p:sp>
+        <p:nvSpPr>
+          <p:cNvPr id="66" name="TextBox 65"/>
+          <p:cNvSpPr txBox="1"/>
+          <p:nvPr/>
+        </p:nvSpPr>
+        <p:spPr>
+          <a:xfrm>
+            <a:off x="2396430" y="7420719"/>
+            <a:ext cx="874216" cy="597694"/>
+          </a:xfrm>
+          <a:prstGeom prst="rect">
+            <a:avLst/>
+          </a:prstGeom>
+          <a:noFill/>
+        </p:spPr>
+        <p:txBody>
+          <a:bodyPr wrap="none" lIns="0" rIns="0" tIns="0" bIns="0" anchor="ctr">
+            <a:spAutoFit/>
+          </a:bodyPr>
+          <a:lstStyle/>
+          <a:p>
+            <a:pPr algn="ctr"/>
+            <a:r>
+              <a:rPr sz="1500" b="0" i="0">
+                <a:solidFill>
+                  <a:srgbClr val="1F2A44"/>
+                </a:solidFill>
+                <a:latin typeface="Playfair Display"/>
+              </a:rPr>
+              <a:t>10</a:t>
+            </a:r>
+          </a:p>
+        </p:txBody>
+      </p:sp>
+      <p:sp>
+        <p:nvSpPr>
           <p:cNvPr id="67" name="TextBox 66"/>
           <p:cNvSpPr txBox="1"/>
           <p:nvPr/>
         </p:nvSpPr>
         <p:spPr>
           <a:xfrm>
-            <a:off x="647998" y="7430244"/>
+            <a:off x="3270647" y="7420719"/>
             <a:ext cx="874216" cy="597694"/>
           </a:xfrm>
           <a:prstGeom prst="rect">
@@ -5285,13 +5300,13 @@
           <a:p>
             <a:pPr algn="ctr"/>
             <a:r>
-              <a:rPr sz="1500" b="1" i="0">
+              <a:rPr sz="1500" b="0" i="0">
                 <a:solidFill>
                   <a:srgbClr val="1F2A44"/>
                 </a:solidFill>
                 <a:latin typeface="Playfair Display"/>
               </a:rPr>
-              <a:t>12</a:t>
+              <a:t>38</a:t>
             </a:r>
           </a:p>
         </p:txBody>
@@ -5304,7 +5319,7 @@
         </p:nvSpPr>
         <p:spPr>
           <a:xfrm>
-            <a:off x="1522214" y="7430244"/>
+            <a:off x="4288780" y="7420719"/>
             <a:ext cx="874216" cy="597694"/>
           </a:xfrm>
           <a:prstGeom prst="rect">
@@ -5326,7 +5341,7 @@
                 </a:solidFill>
                 <a:latin typeface="Playfair Display"/>
               </a:rPr>
-              <a:t>12</a:t>
+              <a:t>40</a:t>
             </a:r>
           </a:p>
         </p:txBody>
@@ -5339,7 +5354,7 @@
         </p:nvSpPr>
         <p:spPr>
           <a:xfrm>
-            <a:off x="2396430" y="7430244"/>
+            <a:off x="5162996" y="7420719"/>
             <a:ext cx="874216" cy="597694"/>
           </a:xfrm>
           <a:prstGeom prst="rect">
@@ -5361,7 +5376,7 @@
                 </a:solidFill>
                 <a:latin typeface="Playfair Display"/>
               </a:rPr>
-              <a:t>10</a:t>
+              <a:t>30</a:t>
             </a:r>
           </a:p>
         </p:txBody>
@@ -5374,8 +5389,8 @@
         </p:nvSpPr>
         <p:spPr>
           <a:xfrm>
-            <a:off x="3270647" y="7430244"/>
-            <a:ext cx="874216" cy="597694"/>
+            <a:off x="6037213" y="7420719"/>
+            <a:ext cx="874663" cy="597694"/>
           </a:xfrm>
           <a:prstGeom prst="rect">
             <a:avLst/>
@@ -5396,111 +5411,6 @@
                 </a:solidFill>
                 <a:latin typeface="Playfair Display"/>
               </a:rPr>
-              <a:t>38</a:t>
-            </a:r>
-          </a:p>
-        </p:txBody>
-      </p:sp>
-      <p:sp>
-        <p:nvSpPr>
-          <p:cNvPr id="71" name="TextBox 70"/>
-          <p:cNvSpPr txBox="1"/>
-          <p:nvPr/>
-        </p:nvSpPr>
-        <p:spPr>
-          <a:xfrm>
-            <a:off x="4288780" y="7430244"/>
-            <a:ext cx="874216" cy="597694"/>
-          </a:xfrm>
-          <a:prstGeom prst="rect">
-            <a:avLst/>
-          </a:prstGeom>
-          <a:noFill/>
-        </p:spPr>
-        <p:txBody>
-          <a:bodyPr wrap="none" lIns="0" rIns="0" tIns="0" bIns="0" anchor="ctr">
-            <a:spAutoFit/>
-          </a:bodyPr>
-          <a:lstStyle/>
-          <a:p>
-            <a:pPr algn="ctr"/>
-            <a:r>
-              <a:rPr sz="1500" b="0" i="0">
-                <a:solidFill>
-                  <a:srgbClr val="1F2A44"/>
-                </a:solidFill>
-                <a:latin typeface="Playfair Display"/>
-              </a:rPr>
-              <a:t>40</a:t>
-            </a:r>
-          </a:p>
-        </p:txBody>
-      </p:sp>
-      <p:sp>
-        <p:nvSpPr>
-          <p:cNvPr id="72" name="TextBox 71"/>
-          <p:cNvSpPr txBox="1"/>
-          <p:nvPr/>
-        </p:nvSpPr>
-        <p:spPr>
-          <a:xfrm>
-            <a:off x="5162996" y="7430244"/>
-            <a:ext cx="874216" cy="597694"/>
-          </a:xfrm>
-          <a:prstGeom prst="rect">
-            <a:avLst/>
-          </a:prstGeom>
-          <a:noFill/>
-        </p:spPr>
-        <p:txBody>
-          <a:bodyPr wrap="none" lIns="0" rIns="0" tIns="0" bIns="0" anchor="ctr">
-            <a:spAutoFit/>
-          </a:bodyPr>
-          <a:lstStyle/>
-          <a:p>
-            <a:pPr algn="ctr"/>
-            <a:r>
-              <a:rPr sz="1500" b="0" i="0">
-                <a:solidFill>
-                  <a:srgbClr val="1F2A44"/>
-                </a:solidFill>
-                <a:latin typeface="Playfair Display"/>
-              </a:rPr>
-              <a:t>30</a:t>
-            </a:r>
-          </a:p>
-        </p:txBody>
-      </p:sp>
-      <p:sp>
-        <p:nvSpPr>
-          <p:cNvPr id="73" name="TextBox 72"/>
-          <p:cNvSpPr txBox="1"/>
-          <p:nvPr/>
-        </p:nvSpPr>
-        <p:spPr>
-          <a:xfrm>
-            <a:off x="6037213" y="7430244"/>
-            <a:ext cx="874663" cy="597694"/>
-          </a:xfrm>
-          <a:prstGeom prst="rect">
-            <a:avLst/>
-          </a:prstGeom>
-          <a:noFill/>
-        </p:spPr>
-        <p:txBody>
-          <a:bodyPr wrap="none" lIns="0" rIns="0" tIns="0" bIns="0" anchor="ctr">
-            <a:spAutoFit/>
-          </a:bodyPr>
-          <a:lstStyle/>
-          <a:p>
-            <a:pPr algn="ctr"/>
-            <a:r>
-              <a:rPr sz="1500" b="0" i="0">
-                <a:solidFill>
-                  <a:srgbClr val="1F2A44"/>
-                </a:solidFill>
-                <a:latin typeface="Playfair Display"/>
-              </a:rPr>
               <a:t>L</a:t>
             </a:r>
           </a:p>
@@ -5508,13 +5418,13 @@
       </p:sp>
       <p:sp>
         <p:nvSpPr>
-          <p:cNvPr id="74" name="Rectangle 73"/>
+          <p:cNvPr id="71" name="Rectangle 70"/>
           <p:cNvSpPr/>
           <p:nvPr/>
         </p:nvSpPr>
         <p:spPr>
           <a:xfrm>
-            <a:off x="647998" y="8027938"/>
+            <a:off x="647998" y="8018413"/>
             <a:ext cx="3496866" cy="597694"/>
           </a:xfrm>
           <a:prstGeom prst="rect">
@@ -5538,13 +5448,13 @@
       </p:sp>
       <p:sp>
         <p:nvSpPr>
-          <p:cNvPr id="75" name="Rectangle 74"/>
+          <p:cNvPr id="72" name="Rectangle 71"/>
           <p:cNvSpPr/>
           <p:nvPr/>
         </p:nvSpPr>
         <p:spPr>
           <a:xfrm>
-            <a:off x="647998" y="8618488"/>
+            <a:off x="647998" y="8608963"/>
             <a:ext cx="3496866" cy="7144"/>
           </a:xfrm>
           <a:prstGeom prst="rect">
@@ -5568,13 +5478,13 @@
       </p:sp>
       <p:sp>
         <p:nvSpPr>
-          <p:cNvPr id="76" name="Rectangle 75"/>
+          <p:cNvPr id="73" name="Rectangle 72"/>
           <p:cNvSpPr/>
           <p:nvPr/>
         </p:nvSpPr>
         <p:spPr>
           <a:xfrm>
-            <a:off x="4288780" y="8027938"/>
+            <a:off x="4288780" y="8018413"/>
             <a:ext cx="2623096" cy="597694"/>
           </a:xfrm>
           <a:prstGeom prst="rect">
@@ -5598,13 +5508,13 @@
       </p:sp>
       <p:sp>
         <p:nvSpPr>
-          <p:cNvPr id="77" name="Rectangle 76"/>
+          <p:cNvPr id="74" name="Rectangle 73"/>
           <p:cNvSpPr/>
           <p:nvPr/>
         </p:nvSpPr>
         <p:spPr>
           <a:xfrm>
-            <a:off x="4288780" y="8618488"/>
+            <a:off x="4288780" y="8608963"/>
             <a:ext cx="2623096" cy="7144"/>
           </a:xfrm>
           <a:prstGeom prst="rect">
@@ -5628,13 +5538,118 @@
       </p:sp>
       <p:sp>
         <p:nvSpPr>
+          <p:cNvPr id="75" name="TextBox 74"/>
+          <p:cNvSpPr txBox="1"/>
+          <p:nvPr/>
+        </p:nvSpPr>
+        <p:spPr>
+          <a:xfrm>
+            <a:off x="647998" y="8018413"/>
+            <a:ext cx="874216" cy="597694"/>
+          </a:xfrm>
+          <a:prstGeom prst="rect">
+            <a:avLst/>
+          </a:prstGeom>
+          <a:noFill/>
+        </p:spPr>
+        <p:txBody>
+          <a:bodyPr wrap="none" lIns="0" rIns="0" tIns="0" bIns="0" anchor="ctr">
+            <a:spAutoFit/>
+          </a:bodyPr>
+          <a:lstStyle/>
+          <a:p>
+            <a:pPr algn="ctr"/>
+            <a:r>
+              <a:rPr sz="1500" b="1" i="0">
+                <a:solidFill>
+                  <a:srgbClr val="1F2A44"/>
+                </a:solidFill>
+                <a:latin typeface="Playfair Display"/>
+              </a:rPr>
+              <a:t>14</a:t>
+            </a:r>
+          </a:p>
+        </p:txBody>
+      </p:sp>
+      <p:sp>
+        <p:nvSpPr>
+          <p:cNvPr id="76" name="TextBox 75"/>
+          <p:cNvSpPr txBox="1"/>
+          <p:nvPr/>
+        </p:nvSpPr>
+        <p:spPr>
+          <a:xfrm>
+            <a:off x="1522214" y="8018413"/>
+            <a:ext cx="874216" cy="597694"/>
+          </a:xfrm>
+          <a:prstGeom prst="rect">
+            <a:avLst/>
+          </a:prstGeom>
+          <a:noFill/>
+        </p:spPr>
+        <p:txBody>
+          <a:bodyPr wrap="none" lIns="0" rIns="0" tIns="0" bIns="0" anchor="ctr">
+            <a:spAutoFit/>
+          </a:bodyPr>
+          <a:lstStyle/>
+          <a:p>
+            <a:pPr algn="ctr"/>
+            <a:r>
+              <a:rPr sz="1500" b="0" i="0">
+                <a:solidFill>
+                  <a:srgbClr val="1F2A44"/>
+                </a:solidFill>
+                <a:latin typeface="Playfair Display"/>
+              </a:rPr>
+              <a:t>14</a:t>
+            </a:r>
+          </a:p>
+        </p:txBody>
+      </p:sp>
+      <p:sp>
+        <p:nvSpPr>
+          <p:cNvPr id="77" name="TextBox 76"/>
+          <p:cNvSpPr txBox="1"/>
+          <p:nvPr/>
+        </p:nvSpPr>
+        <p:spPr>
+          <a:xfrm>
+            <a:off x="2396430" y="8018413"/>
+            <a:ext cx="874216" cy="597694"/>
+          </a:xfrm>
+          <a:prstGeom prst="rect">
+            <a:avLst/>
+          </a:prstGeom>
+          <a:noFill/>
+        </p:spPr>
+        <p:txBody>
+          <a:bodyPr wrap="none" lIns="0" rIns="0" tIns="0" bIns="0" anchor="ctr">
+            <a:spAutoFit/>
+          </a:bodyPr>
+          <a:lstStyle/>
+          <a:p>
+            <a:pPr algn="ctr"/>
+            <a:r>
+              <a:rPr sz="1500" b="0" i="0">
+                <a:solidFill>
+                  <a:srgbClr val="1F2A44"/>
+                </a:solidFill>
+                <a:latin typeface="Playfair Display"/>
+              </a:rPr>
+              <a:t>12</a:t>
+            </a:r>
+          </a:p>
+        </p:txBody>
+      </p:sp>
+      <p:sp>
+        <p:nvSpPr>
           <p:cNvPr id="78" name="TextBox 77"/>
           <p:cNvSpPr txBox="1"/>
           <p:nvPr/>
         </p:nvSpPr>
         <p:spPr>
           <a:xfrm>
-            <a:off x="647998" y="8027938"/>
+            <a:off x="3270647" y="8018413"/>
             <a:ext cx="874216" cy="597694"/>
           </a:xfrm>
           <a:prstGeom prst="rect">
@@ -5650,13 +5665,13 @@
           <a:p>
             <a:pPr algn="ctr"/>
             <a:r>
-              <a:rPr sz="1500" b="1" i="0">
+              <a:rPr sz="1500" b="0" i="0">
                 <a:solidFill>
                   <a:srgbClr val="1F2A44"/>
                 </a:solidFill>
                 <a:latin typeface="Playfair Display"/>
               </a:rPr>
-              <a:t>14</a:t>
+              <a:t>40</a:t>
             </a:r>
           </a:p>
         </p:txBody>
@@ -5669,7 +5684,7 @@
         </p:nvSpPr>
         <p:spPr>
           <a:xfrm>
-            <a:off x="1522214" y="8027938"/>
+            <a:off x="4288780" y="8018413"/>
             <a:ext cx="874216" cy="597694"/>
           </a:xfrm>
           <a:prstGeom prst="rect">
@@ -5691,7 +5706,7 @@
                 </a:solidFill>
                 <a:latin typeface="Playfair Display"/>
               </a:rPr>
-              <a:t>14</a:t>
+              <a:t>42</a:t>
             </a:r>
           </a:p>
         </p:txBody>
@@ -5704,7 +5719,7 @@
         </p:nvSpPr>
         <p:spPr>
           <a:xfrm>
-            <a:off x="2396430" y="8027938"/>
+            <a:off x="5162996" y="8018413"/>
             <a:ext cx="874216" cy="597694"/>
           </a:xfrm>
           <a:prstGeom prst="rect">
@@ -5726,7 +5741,7 @@
                 </a:solidFill>
                 <a:latin typeface="Playfair Display"/>
               </a:rPr>
-              <a:t>12</a:t>
+              <a:t>31</a:t>
             </a:r>
           </a:p>
         </p:txBody>
@@ -5739,8 +5754,8 @@
         </p:nvSpPr>
         <p:spPr>
           <a:xfrm>
-            <a:off x="3270647" y="8027938"/>
-            <a:ext cx="874216" cy="597694"/>
+            <a:off x="6037213" y="8018413"/>
+            <a:ext cx="874663" cy="597694"/>
           </a:xfrm>
           <a:prstGeom prst="rect">
             <a:avLst/>
@@ -5761,111 +5776,6 @@
                 </a:solidFill>
                 <a:latin typeface="Playfair Display"/>
               </a:rPr>
-              <a:t>40</a:t>
-            </a:r>
-          </a:p>
-        </p:txBody>
-      </p:sp>
-      <p:sp>
-        <p:nvSpPr>
-          <p:cNvPr id="82" name="TextBox 81"/>
-          <p:cNvSpPr txBox="1"/>
-          <p:nvPr/>
-        </p:nvSpPr>
-        <p:spPr>
-          <a:xfrm>
-            <a:off x="4288780" y="8027938"/>
-            <a:ext cx="874216" cy="597694"/>
-          </a:xfrm>
-          <a:prstGeom prst="rect">
-            <a:avLst/>
-          </a:prstGeom>
-          <a:noFill/>
-        </p:spPr>
-        <p:txBody>
-          <a:bodyPr wrap="none" lIns="0" rIns="0" tIns="0" bIns="0" anchor="ctr">
-            <a:spAutoFit/>
-          </a:bodyPr>
-          <a:lstStyle/>
-          <a:p>
-            <a:pPr algn="ctr"/>
-            <a:r>
-              <a:rPr sz="1500" b="0" i="0">
-                <a:solidFill>
-                  <a:srgbClr val="1F2A44"/>
-                </a:solidFill>
-                <a:latin typeface="Playfair Display"/>
-              </a:rPr>
-              <a:t>42</a:t>
-            </a:r>
-          </a:p>
-        </p:txBody>
-      </p:sp>
-      <p:sp>
-        <p:nvSpPr>
-          <p:cNvPr id="83" name="TextBox 82"/>
-          <p:cNvSpPr txBox="1"/>
-          <p:nvPr/>
-        </p:nvSpPr>
-        <p:spPr>
-          <a:xfrm>
-            <a:off x="5162996" y="8027938"/>
-            <a:ext cx="874216" cy="597694"/>
-          </a:xfrm>
-          <a:prstGeom prst="rect">
-            <a:avLst/>
-          </a:prstGeom>
-          <a:noFill/>
-        </p:spPr>
-        <p:txBody>
-          <a:bodyPr wrap="none" lIns="0" rIns="0" tIns="0" bIns="0" anchor="ctr">
-            <a:spAutoFit/>
-          </a:bodyPr>
-          <a:lstStyle/>
-          <a:p>
-            <a:pPr algn="ctr"/>
-            <a:r>
-              <a:rPr sz="1500" b="0" i="0">
-                <a:solidFill>
-                  <a:srgbClr val="1F2A44"/>
-                </a:solidFill>
-                <a:latin typeface="Playfair Display"/>
-              </a:rPr>
-              <a:t>31</a:t>
-            </a:r>
-          </a:p>
-        </p:txBody>
-      </p:sp>
-      <p:sp>
-        <p:nvSpPr>
-          <p:cNvPr id="84" name="TextBox 83"/>
-          <p:cNvSpPr txBox="1"/>
-          <p:nvPr/>
-        </p:nvSpPr>
-        <p:spPr>
-          <a:xfrm>
-            <a:off x="6037213" y="8027938"/>
-            <a:ext cx="874663" cy="597694"/>
-          </a:xfrm>
-          <a:prstGeom prst="rect">
-            <a:avLst/>
-          </a:prstGeom>
-          <a:noFill/>
-        </p:spPr>
-        <p:txBody>
-          <a:bodyPr wrap="none" lIns="0" rIns="0" tIns="0" bIns="0" anchor="ctr">
-            <a:spAutoFit/>
-          </a:bodyPr>
-          <a:lstStyle/>
-          <a:p>
-            <a:pPr algn="ctr"/>
-            <a:r>
-              <a:rPr sz="1500" b="0" i="0">
-                <a:solidFill>
-                  <a:srgbClr val="1F2A44"/>
-                </a:solidFill>
-                <a:latin typeface="Playfair Display"/>
-              </a:rPr>
               <a:t>L</a:t>
             </a:r>
           </a:p>
@@ -5873,13 +5783,13 @@
       </p:sp>
       <p:sp>
         <p:nvSpPr>
-          <p:cNvPr id="85" name="Rectangle 84"/>
+          <p:cNvPr id="82" name="Rectangle 81"/>
           <p:cNvSpPr/>
           <p:nvPr/>
         </p:nvSpPr>
         <p:spPr>
           <a:xfrm>
-            <a:off x="647998" y="9216182"/>
+            <a:off x="647998" y="9206657"/>
             <a:ext cx="3496866" cy="7144"/>
           </a:xfrm>
           <a:prstGeom prst="rect">
@@ -5903,13 +5813,13 @@
       </p:sp>
       <p:sp>
         <p:nvSpPr>
-          <p:cNvPr id="86" name="Rectangle 85"/>
+          <p:cNvPr id="83" name="Rectangle 82"/>
           <p:cNvSpPr/>
           <p:nvPr/>
         </p:nvSpPr>
         <p:spPr>
           <a:xfrm>
-            <a:off x="4288780" y="9216182"/>
+            <a:off x="4288780" y="9206657"/>
             <a:ext cx="2623096" cy="7144"/>
           </a:xfrm>
           <a:prstGeom prst="rect">
@@ -5933,13 +5843,118 @@
       </p:sp>
       <p:sp>
         <p:nvSpPr>
+          <p:cNvPr id="84" name="TextBox 83"/>
+          <p:cNvSpPr txBox="1"/>
+          <p:nvPr/>
+        </p:nvSpPr>
+        <p:spPr>
+          <a:xfrm>
+            <a:off x="647998" y="8616107"/>
+            <a:ext cx="874216" cy="597694"/>
+          </a:xfrm>
+          <a:prstGeom prst="rect">
+            <a:avLst/>
+          </a:prstGeom>
+          <a:noFill/>
+        </p:spPr>
+        <p:txBody>
+          <a:bodyPr wrap="none" lIns="0" rIns="0" tIns="0" bIns="0" anchor="ctr">
+            <a:spAutoFit/>
+          </a:bodyPr>
+          <a:lstStyle/>
+          <a:p>
+            <a:pPr algn="ctr"/>
+            <a:r>
+              <a:rPr sz="1500" b="1" i="0">
+                <a:solidFill>
+                  <a:srgbClr val="1F2A44"/>
+                </a:solidFill>
+                <a:latin typeface="Playfair Display"/>
+              </a:rPr>
+              <a:t>16</a:t>
+            </a:r>
+          </a:p>
+        </p:txBody>
+      </p:sp>
+      <p:sp>
+        <p:nvSpPr>
+          <p:cNvPr id="85" name="TextBox 84"/>
+          <p:cNvSpPr txBox="1"/>
+          <p:nvPr/>
+        </p:nvSpPr>
+        <p:spPr>
+          <a:xfrm>
+            <a:off x="1522214" y="8616107"/>
+            <a:ext cx="874216" cy="597694"/>
+          </a:xfrm>
+          <a:prstGeom prst="rect">
+            <a:avLst/>
+          </a:prstGeom>
+          <a:noFill/>
+        </p:spPr>
+        <p:txBody>
+          <a:bodyPr wrap="none" lIns="0" rIns="0" tIns="0" bIns="0" anchor="ctr">
+            <a:spAutoFit/>
+          </a:bodyPr>
+          <a:lstStyle/>
+          <a:p>
+            <a:pPr algn="ctr"/>
+            <a:r>
+              <a:rPr sz="1500" b="0" i="0">
+                <a:solidFill>
+                  <a:srgbClr val="1F2A44"/>
+                </a:solidFill>
+                <a:latin typeface="Playfair Display"/>
+              </a:rPr>
+              <a:t>16</a:t>
+            </a:r>
+          </a:p>
+        </p:txBody>
+      </p:sp>
+      <p:sp>
+        <p:nvSpPr>
+          <p:cNvPr id="86" name="TextBox 85"/>
+          <p:cNvSpPr txBox="1"/>
+          <p:nvPr/>
+        </p:nvSpPr>
+        <p:spPr>
+          <a:xfrm>
+            <a:off x="2396430" y="8616107"/>
+            <a:ext cx="874216" cy="597694"/>
+          </a:xfrm>
+          <a:prstGeom prst="rect">
+            <a:avLst/>
+          </a:prstGeom>
+          <a:noFill/>
+        </p:spPr>
+        <p:txBody>
+          <a:bodyPr wrap="none" lIns="0" rIns="0" tIns="0" bIns="0" anchor="ctr">
+            <a:spAutoFit/>
+          </a:bodyPr>
+          <a:lstStyle/>
+          <a:p>
+            <a:pPr algn="ctr"/>
+            <a:r>
+              <a:rPr sz="1500" b="0" i="0">
+                <a:solidFill>
+                  <a:srgbClr val="1F2A44"/>
+                </a:solidFill>
+                <a:latin typeface="Playfair Display"/>
+              </a:rPr>
+              <a:t>14</a:t>
+            </a:r>
+          </a:p>
+        </p:txBody>
+      </p:sp>
+      <p:sp>
+        <p:nvSpPr>
           <p:cNvPr id="87" name="TextBox 86"/>
           <p:cNvSpPr txBox="1"/>
           <p:nvPr/>
         </p:nvSpPr>
         <p:spPr>
           <a:xfrm>
-            <a:off x="647998" y="8625632"/>
+            <a:off x="3270647" y="8616107"/>
             <a:ext cx="874216" cy="597694"/>
           </a:xfrm>
           <a:prstGeom prst="rect">
@@ -5955,13 +5970,13 @@
           <a:p>
             <a:pPr algn="ctr"/>
             <a:r>
-              <a:rPr sz="1500" b="1" i="0">
+              <a:rPr sz="1500" b="0" i="0">
                 <a:solidFill>
                   <a:srgbClr val="1F2A44"/>
                 </a:solidFill>
                 <a:latin typeface="Playfair Display"/>
               </a:rPr>
-              <a:t>16</a:t>
+              <a:t>42</a:t>
             </a:r>
           </a:p>
         </p:txBody>
@@ -5974,7 +5989,7 @@
         </p:nvSpPr>
         <p:spPr>
           <a:xfrm>
-            <a:off x="1522214" y="8625632"/>
+            <a:off x="4288780" y="8616107"/>
             <a:ext cx="874216" cy="597694"/>
           </a:xfrm>
           <a:prstGeom prst="rect">
@@ -5996,7 +6011,7 @@
                 </a:solidFill>
                 <a:latin typeface="Playfair Display"/>
               </a:rPr>
-              <a:t>16</a:t>
+              <a:t>44</a:t>
             </a:r>
           </a:p>
         </p:txBody>
@@ -6009,7 +6024,7 @@
         </p:nvSpPr>
         <p:spPr>
           <a:xfrm>
-            <a:off x="2396430" y="8625632"/>
+            <a:off x="5162996" y="8616107"/>
             <a:ext cx="874216" cy="597694"/>
           </a:xfrm>
           <a:prstGeom prst="rect">
@@ -6031,7 +6046,7 @@
                 </a:solidFill>
                 <a:latin typeface="Playfair Display"/>
               </a:rPr>
-              <a:t>14</a:t>
+              <a:t>32</a:t>
             </a:r>
           </a:p>
         </p:txBody>
@@ -6044,8 +6059,8 @@
         </p:nvSpPr>
         <p:spPr>
           <a:xfrm>
-            <a:off x="3270647" y="8625632"/>
-            <a:ext cx="874216" cy="597694"/>
+            <a:off x="6037213" y="8616107"/>
+            <a:ext cx="874663" cy="597694"/>
           </a:xfrm>
           <a:prstGeom prst="rect">
             <a:avLst/>
@@ -6066,111 +6081,6 @@
                 </a:solidFill>
                 <a:latin typeface="Playfair Display"/>
               </a:rPr>
-              <a:t>42</a:t>
-            </a:r>
-          </a:p>
-        </p:txBody>
-      </p:sp>
-      <p:sp>
-        <p:nvSpPr>
-          <p:cNvPr id="91" name="TextBox 90"/>
-          <p:cNvSpPr txBox="1"/>
-          <p:nvPr/>
-        </p:nvSpPr>
-        <p:spPr>
-          <a:xfrm>
-            <a:off x="4288780" y="8625632"/>
-            <a:ext cx="874216" cy="597694"/>
-          </a:xfrm>
-          <a:prstGeom prst="rect">
-            <a:avLst/>
-          </a:prstGeom>
-          <a:noFill/>
-        </p:spPr>
-        <p:txBody>
-          <a:bodyPr wrap="none" lIns="0" rIns="0" tIns="0" bIns="0" anchor="ctr">
-            <a:spAutoFit/>
-          </a:bodyPr>
-          <a:lstStyle/>
-          <a:p>
-            <a:pPr algn="ctr"/>
-            <a:r>
-              <a:rPr sz="1500" b="0" i="0">
-                <a:solidFill>
-                  <a:srgbClr val="1F2A44"/>
-                </a:solidFill>
-                <a:latin typeface="Playfair Display"/>
-              </a:rPr>
-              <a:t>44</a:t>
-            </a:r>
-          </a:p>
-        </p:txBody>
-      </p:sp>
-      <p:sp>
-        <p:nvSpPr>
-          <p:cNvPr id="92" name="TextBox 91"/>
-          <p:cNvSpPr txBox="1"/>
-          <p:nvPr/>
-        </p:nvSpPr>
-        <p:spPr>
-          <a:xfrm>
-            <a:off x="5162996" y="8625632"/>
-            <a:ext cx="874216" cy="597694"/>
-          </a:xfrm>
-          <a:prstGeom prst="rect">
-            <a:avLst/>
-          </a:prstGeom>
-          <a:noFill/>
-        </p:spPr>
-        <p:txBody>
-          <a:bodyPr wrap="none" lIns="0" rIns="0" tIns="0" bIns="0" anchor="ctr">
-            <a:spAutoFit/>
-          </a:bodyPr>
-          <a:lstStyle/>
-          <a:p>
-            <a:pPr algn="ctr"/>
-            <a:r>
-              <a:rPr sz="1500" b="0" i="0">
-                <a:solidFill>
-                  <a:srgbClr val="1F2A44"/>
-                </a:solidFill>
-                <a:latin typeface="Playfair Display"/>
-              </a:rPr>
-              <a:t>32</a:t>
-            </a:r>
-          </a:p>
-        </p:txBody>
-      </p:sp>
-      <p:sp>
-        <p:nvSpPr>
-          <p:cNvPr id="93" name="TextBox 92"/>
-          <p:cNvSpPr txBox="1"/>
-          <p:nvPr/>
-        </p:nvSpPr>
-        <p:spPr>
-          <a:xfrm>
-            <a:off x="6037213" y="8625632"/>
-            <a:ext cx="874663" cy="597694"/>
-          </a:xfrm>
-          <a:prstGeom prst="rect">
-            <a:avLst/>
-          </a:prstGeom>
-          <a:noFill/>
-        </p:spPr>
-        <p:txBody>
-          <a:bodyPr wrap="none" lIns="0" rIns="0" tIns="0" bIns="0" anchor="ctr">
-            <a:spAutoFit/>
-          </a:bodyPr>
-          <a:lstStyle/>
-          <a:p>
-            <a:pPr algn="ctr"/>
-            <a:r>
-              <a:rPr sz="1500" b="0" i="0">
-                <a:solidFill>
-                  <a:srgbClr val="1F2A44"/>
-                </a:solidFill>
-                <a:latin typeface="Playfair Display"/>
-              </a:rPr>
               <a:t>XL</a:t>
             </a:r>
           </a:p>
@@ -6178,13 +6088,13 @@
       </p:sp>
       <p:sp>
         <p:nvSpPr>
-          <p:cNvPr id="94" name="Rectangle 93"/>
+          <p:cNvPr id="91" name="Rectangle 90"/>
           <p:cNvSpPr/>
           <p:nvPr/>
         </p:nvSpPr>
         <p:spPr>
           <a:xfrm>
-            <a:off x="4288780" y="5044232"/>
+            <a:off x="4288780" y="5034707"/>
             <a:ext cx="7144" cy="4179094"/>
           </a:xfrm>
           <a:prstGeom prst="rect">
@@ -6208,13 +6118,13 @@
       </p:sp>
       <p:sp>
         <p:nvSpPr>
-          <p:cNvPr id="95" name="TextBox 94"/>
+          <p:cNvPr id="92" name="TextBox 91"/>
           <p:cNvSpPr txBox="1"/>
           <p:nvPr/>
         </p:nvSpPr>
         <p:spPr>
           <a:xfrm>
-            <a:off x="2154882" y="9516070"/>
+            <a:off x="2154882" y="9506545"/>
             <a:ext cx="3249960" cy="325041"/>
           </a:xfrm>
           <a:prstGeom prst="rect">
@@ -6255,43 +6165,13 @@
       </p:sp>
       <p:sp>
         <p:nvSpPr>
-          <p:cNvPr id="96" name="Rectangle 95"/>
-          <p:cNvSpPr/>
-          <p:nvPr/>
-        </p:nvSpPr>
-        <p:spPr>
-          <a:xfrm>
-            <a:off x="3563838" y="10057061"/>
-            <a:ext cx="431899" cy="7144"/>
-          </a:xfrm>
-          <a:prstGeom prst="rect">
-            <a:avLst/>
-          </a:prstGeom>
-          <a:solidFill>
-            <a:srgbClr val="9E7A38"/>
-          </a:solidFill>
-          <a:ln>
-            <a:noFill/>
-          </a:ln>
-          <a:effectLst/>
-        </p:spPr>
-        <p:txBody>
-          <a:bodyPr rtlCol="0" anchor="ctr"/>
-          <a:lstStyle/>
-          <a:p>
-            <a:pPr algn="ctr"/>
-          </a:p>
-        </p:txBody>
-      </p:sp>
-      <p:sp>
-        <p:nvSpPr>
-          <p:cNvPr id="97" name="TextBox 96"/>
+          <p:cNvPr id="93" name="TextBox 92"/>
           <p:cNvSpPr txBox="1"/>
           <p:nvPr/>
         </p:nvSpPr>
         <p:spPr>
           <a:xfrm>
-            <a:off x="2092672" y="10174486"/>
+            <a:off x="2092672" y="10047536"/>
             <a:ext cx="3374380" cy="123825"/>
           </a:xfrm>
           <a:prstGeom prst="rect">

</xml_diff>

<commit_message>
Note wording: 'Our team are happy'
Co-Authored-By: Claude Opus 5.5 <noreply@anthropic.com>
Claude-Session: https://claude.ai/code/session_01JDwQw7JjDqKz2VPXW7wT25
</commit_message>
<xml_diff>
--- a/size-charts/womens-pant-size-chart-canva.pptx
+++ b/size-charts/womens-pant-size-chart-canva.pptx
@@ -6124,8 +6124,8 @@
         </p:nvSpPr>
         <p:spPr>
           <a:xfrm>
-            <a:off x="2154882" y="9506545"/>
-            <a:ext cx="3249960" cy="325041"/>
+            <a:off x="2109936" y="9506545"/>
+            <a:ext cx="3339852" cy="325041"/>
           </a:xfrm>
           <a:prstGeom prst="rect">
             <a:avLst/>
@@ -6158,7 +6158,7 @@
                 </a:solidFill>
                 <a:latin typeface="Montserrat"/>
               </a:rPr>
-              <a:t>Our team is happy to help you find your perfect fit.</a:t>
+              <a:t>Our team are happy to help you find your perfect fit.</a:t>
             </a:r>
           </a:p>
         </p:txBody>

</xml_diff>